<commit_message>
Real local language model (llama3.2:3b via Ollama), no mock; grounded extraction, validated letters; model robustness tests; report, deck and README updated
</commit_message>
<xml_diff>
--- a/docs/ClaimsAgent_CA3.pptx
+++ b/docs/ClaimsAgent_CA3.pptx
@@ -16,9 +16,10 @@
     <p:sldId id="264" r:id="rId10"/>
     <p:sldId id="265" r:id="rId11"/>
     <p:sldId id="266" r:id="rId12"/>
+    <p:sldId id="267" r:id="rId13"/>
   </p:sldIdLst>
   <p:notesMasterIdLst>
-    <p:notesMasterId r:id="rId13"/>
+    <p:notesMasterId r:id="rId14"/>
   </p:notesMasterIdLst>
   <p:sldSz cx="9144000" cy="5143500"/>
   <p:notesSz cx="5143500" cy="9144000"/>
@@ -117,17 +118,17 @@
   <p:extLst>
     <p:ext uri="{521415D9-36F7-43E2-AB2F-B90AF26B5E84}">
       <p14:sectionLst xmlns:p14="http://schemas.microsoft.com/office/powerpoint/2010/main">
-        <p14:section name="Opening" id="{bccf1a17-b97d-96d0-2fcb-007820aa0fcd}">
+        <p14:section name="Opening" id="{432cef51-519c-6b96-d779-631be63cadc9}">
           <p14:sldIdLst>
             <p14:sldId id="256"/>
           </p14:sldIdLst>
         </p14:section>
-        <p14:section name="Problem" id="{95cc6792-ae7c-35ba-5b43-b9f80f38ec70}">
+        <p14:section name="Problem" id="{56043ce9-db0e-a8f4-ecb0-a0ddc66aac87}">
           <p14:sldIdLst>
             <p14:sldId id="257"/>
           </p14:sldIdLst>
         </p14:section>
-        <p14:section name="Solution" id="{a9ffcb44-236f-0eb1-bcf9-e85fc3430c5e}">
+        <p14:section name="Solution" id="{3823349e-6645-23ae-5b21-8c724c3a8660}">
           <p14:sldIdLst>
             <p14:sldId id="258"/>
             <p14:sldId id="259"/>
@@ -135,21 +136,22 @@
             <p14:sldId id="261"/>
           </p14:sldIdLst>
         </p14:section>
-        <p14:section name="Validation" id="{75084c3f-ea0a-3200-d7d3-bc0275a89d99}">
+        <p14:section name="Validation" id="{22e0d75f-5f60-aa38-ad0b-0f726732c3a9}">
           <p14:sldIdLst>
             <p14:sldId id="262"/>
+            <p14:sldId id="263"/>
           </p14:sldIdLst>
         </p14:section>
-        <p14:section name="Close" id="{c47f1182-5003-f5ca-b168-020bf0a950a1}">
+        <p14:section name="Close" id="{ce7b2eb3-75bf-bcd0-615f-ebd7c5bd7c2c}">
           <p14:sldIdLst>
-            <p14:sldId id="263"/>
             <p14:sldId id="264"/>
+            <p14:sldId id="265"/>
           </p14:sldIdLst>
         </p14:section>
-        <p14:section name="Appendix" id="{3da590cd-270c-3947-a1cf-f6d30844c375}">
+        <p14:section name="Appendix" id="{6e395425-b760-3db8-add8-95d6f7a1d792}">
           <p14:sldIdLst>
-            <p14:sldId id="265"/>
             <p14:sldId id="266"/>
+            <p14:sldId id="267"/>
           </p14:sldIdLst>
         </p14:section>
       </p14:sectionLst>
@@ -249,9 +251,9 @@
           </c:dLbls>
           <c:cat>
             <c:multiLvlStrRef>
-              <c:f>Sheet1!$A$2:$A$10</c:f>
+              <c:f>Sheet1!$A$2:$A$11</c:f>
               <c:multiLvlStrCache>
-                <c:ptCount val="9"/>
+                <c:ptCount val="10"/>
                 <c:lvl>
                   <c:pt idx="0">
                     <c:v>Clean, held-out</c:v>
@@ -280,16 +282,19 @@
                   <c:pt idx="8">
                     <c:v>UNSEEN: abbreviations</c:v>
                   </c:pt>
+                  <c:pt idx="9">
+                    <c:v>UNSEEN: telegraphic notes</c:v>
+                  </c:pt>
                 </c:lvl>
               </c:multiLvlStrCache>
             </c:multiLvlStrRef>
           </c:cat>
           <c:val>
             <c:numRef>
-              <c:f>Sheet1!$B$2:$B$10</c:f>
+              <c:f>Sheet1!$B$2:$B$11</c:f>
               <c:numCache>
                 <c:formatCode>General</c:formatCode>
-                <c:ptCount val="9"/>
+                <c:ptCount val="10"/>
                 <c:pt idx="0">
                   <c:v>99.1</c:v>
                 </c:pt>
@@ -315,6 +320,9 @@
                   <c:v>0</c:v>
                 </c:pt>
                 <c:pt idx="8">
+                  <c:v>0</c:v>
+                </c:pt>
+                <c:pt idx="9">
                   <c:v>0</c:v>
                 </c:pt>
               </c:numCache>
@@ -368,9 +376,9 @@
           </c:dLbls>
           <c:cat>
             <c:multiLvlStrRef>
-              <c:f>Sheet1!$A$2:$A$10</c:f>
+              <c:f>Sheet1!$A$2:$A$11</c:f>
               <c:multiLvlStrCache>
-                <c:ptCount val="9"/>
+                <c:ptCount val="10"/>
                 <c:lvl>
                   <c:pt idx="0">
                     <c:v>Clean, held-out</c:v>
@@ -399,16 +407,19 @@
                   <c:pt idx="8">
                     <c:v>UNSEEN: abbreviations</c:v>
                   </c:pt>
+                  <c:pt idx="9">
+                    <c:v>UNSEEN: telegraphic notes</c:v>
+                  </c:pt>
                 </c:lvl>
               </c:multiLvlStrCache>
             </c:multiLvlStrRef>
           </c:cat>
           <c:val>
             <c:numRef>
-              <c:f>Sheet1!$C$2:$C$10</c:f>
+              <c:f>Sheet1!$C$2:$C$11</c:f>
               <c:numCache>
                 <c:formatCode>General</c:formatCode>
-                <c:ptCount val="9"/>
+                <c:ptCount val="10"/>
                 <c:pt idx="0">
                   <c:v>100</c:v>
                 </c:pt>
@@ -435,6 +446,9 @@
                 </c:pt>
                 <c:pt idx="8">
                   <c:v>94.8</c:v>
+                </c:pt>
+                <c:pt idx="9">
+                  <c:v>92.6</c:v>
                 </c:pt>
               </c:numCache>
             </c:numRef>
@@ -543,6 +557,381 @@
                   <a:srgbClr val="0B4F5C"/>
                 </a:solidFill>
                 <a:latin typeface="+mn-lt"/>
+              </a:defRPr>
+            </a:pPr>
+            <a:endParaRPr lang="en-US"/>
+          </a:p>
+        </c:txPr>
+        <c:crossAx val="2094734554"/>
+        <c:crosses val="autoZero"/>
+        <c:crossBetween val="between"/>
+      </c:valAx>
+      <c:spPr>
+        <a:noFill/>
+        <a:ln>
+          <a:noFill/>
+        </a:ln>
+        <a:effectLst/>
+      </c:spPr>
+    </c:plotArea>
+    <c:legend>
+      <c:legendPos val="b"/>
+      <c:overlay val="0"/>
+      <c:txPr>
+        <a:bodyPr/>
+        <a:lstStyle/>
+        <a:p>
+          <a:pPr>
+            <a:defRPr sz="1100">
+              <a:solidFill>
+                <a:srgbClr val="12263A"/>
+              </a:solidFill>
+              <a:latin typeface="+mn-lt"/>
+              <a:cs typeface="+mn-lt"/>
+            </a:defRPr>
+          </a:pPr>
+          <a:endParaRPr lang="en-US"/>
+        </a:p>
+      </c:txPr>
+    </c:legend>
+    <c:plotVisOnly val="1"/>
+    <c:dispBlanksAs val="span"/>
+  </c:chart>
+  <c:spPr>
+    <a:noFill/>
+    <a:ln>
+      <a:noFill/>
+    </a:ln>
+    <a:effectLst/>
+  </c:spPr>
+  <c:externalData r:id="rId1">
+    <c:autoUpdate val="0"/>
+  </c:externalData>
+</c:chartSpace>
+</file>
+
+<file path=ppt/charts/chart2.xml><?xml version="1.0" encoding="utf-8"?>
+<c:chartSpace xmlns:c="http://schemas.openxmlformats.org/drawingml/2006/chart" xmlns:a="http://schemas.openxmlformats.org/drawingml/2006/main" xmlns:r="http://schemas.openxmlformats.org/officeDocument/2006/relationships">
+  <c:date1904 val="0"/>
+  <c:roundedCorners val="1"/>
+  <c:chart>
+    <c:title>
+      <c:tx>
+        <c:rich>
+          <a:bodyPr/>
+          <a:lstStyle/>
+          <a:p>
+            <a:pPr>
+              <a:defRPr sz="1300" b="0" i="0" u="none" strike="noStrike">
+                <a:solidFill>
+                  <a:srgbClr val="12263A"/>
+                </a:solidFill>
+                <a:latin typeface="+mn-lt"/>
+              </a:defRPr>
+            </a:pPr>
+            <a:r>
+              <a:rPr sz="1300" b="0" i="0" u="none" strike="noStrike">
+                <a:solidFill>
+                  <a:srgbClr val="12263A"/>
+                </a:solidFill>
+                <a:latin typeface="+mn-lt"/>
+              </a:rPr>
+              <a:t>Accuracy on unseen noise (%)</a:t>
+            </a:r>
+          </a:p>
+        </c:rich>
+      </c:tx>
+      <c:layout/>
+      <c:overlay val="0"/>
+    </c:title>
+    <c:autoTitleDeleted val="0"/>
+    <c:plotArea>
+      <c:layout/>
+      <c:barChart>
+        <c:barDir val="bar"/>
+        <c:grouping val="clustered"/>
+        <c:varyColors val="0"/>
+        <c:ser>
+          <c:idx val="0"/>
+          <c:order val="0"/>
+          <c:tx>
+            <c:strRef>
+              <c:f>Sheet1!$B$1</c:f>
+              <c:strCache>
+                <c:ptCount val="1"/>
+                <c:pt idx="0">
+                  <c:v>Rules only</c:v>
+                </c:pt>
+              </c:strCache>
+            </c:strRef>
+          </c:tx>
+          <c:spPr>
+            <a:solidFill>
+              <a:srgbClr val="A9B8C2"/>
+            </a:solidFill>
+            <a:effectLst/>
+          </c:spPr>
+          <c:invertIfNegative val="0"/>
+          <c:dLbls>
+            <c:numFmt formatCode="0.0" sourceLinked="0"/>
+            <c:txPr>
+              <a:bodyPr/>
+              <a:lstStyle/>
+              <a:p>
+                <a:pPr>
+                  <a:defRPr b="0" i="0" strike="noStrike" sz="1100" u="none">
+                    <a:solidFill>
+                      <a:srgbClr val="12263A"/>
+                    </a:solidFill>
+                    <a:latin typeface="+mn-lt"/>
+                  </a:defRPr>
+                </a:pPr>
+              </a:p>
+            </c:txPr>
+            <c:showLegendKey val="0"/>
+            <c:showVal val="1"/>
+            <c:showCatName val="0"/>
+            <c:showSerName val="0"/>
+            <c:showPercent val="0"/>
+            <c:showBubbleSize val="0"/>
+            <c:showLeaderLines val="0"/>
+          </c:dLbls>
+          <c:cat>
+            <c:multiLvlStrRef>
+              <c:f>Sheet1!$A$2:$A$5</c:f>
+              <c:multiLvlStrCache>
+                <c:ptCount val="4"/>
+                <c:lvl>
+                  <c:pt idx="0">
+                    <c:v>Clean</c:v>
+                  </c:pt>
+                  <c:pt idx="1">
+                    <c:v>Character noise</c:v>
+                  </c:pt>
+                  <c:pt idx="2">
+                    <c:v>Abbreviations</c:v>
+                  </c:pt>
+                  <c:pt idx="3">
+                    <c:v>Telegraphic notes</c:v>
+                  </c:pt>
+                </c:lvl>
+              </c:multiLvlStrCache>
+            </c:multiLvlStrRef>
+          </c:cat>
+          <c:val>
+            <c:numRef>
+              <c:f>Sheet1!$B$2:$B$5</c:f>
+              <c:numCache>
+                <c:formatCode>General</c:formatCode>
+                <c:ptCount val="4"/>
+                <c:pt idx="0">
+                  <c:v>100</c:v>
+                </c:pt>
+                <c:pt idx="1">
+                  <c:v>96.6</c:v>
+                </c:pt>
+                <c:pt idx="2">
+                  <c:v>94.4</c:v>
+                </c:pt>
+                <c:pt idx="3">
+                  <c:v>91</c:v>
+                </c:pt>
+              </c:numCache>
+            </c:numRef>
+          </c:val>
+        </c:ser>
+        <c:ser>
+          <c:idx val="1"/>
+          <c:order val="1"/>
+          <c:tx>
+            <c:strRef>
+              <c:f>Sheet1!$C$1</c:f>
+              <c:strCache>
+                <c:ptCount val="1"/>
+                <c:pt idx="0">
+                  <c:v>With llama3.2:3b</c:v>
+                </c:pt>
+              </c:strCache>
+            </c:strRef>
+          </c:tx>
+          <c:spPr>
+            <a:solidFill>
+              <a:srgbClr val="0F766E"/>
+            </a:solidFill>
+            <a:effectLst/>
+          </c:spPr>
+          <c:invertIfNegative val="0"/>
+          <c:dLbls>
+            <c:numFmt formatCode="0.0" sourceLinked="0"/>
+            <c:txPr>
+              <a:bodyPr/>
+              <a:lstStyle/>
+              <a:p>
+                <a:pPr>
+                  <a:defRPr b="0" i="0" strike="noStrike" sz="1100" u="none">
+                    <a:solidFill>
+                      <a:srgbClr val="12263A"/>
+                    </a:solidFill>
+                    <a:latin typeface="+mn-lt"/>
+                  </a:defRPr>
+                </a:pPr>
+              </a:p>
+            </c:txPr>
+            <c:showLegendKey val="0"/>
+            <c:showVal val="1"/>
+            <c:showCatName val="0"/>
+            <c:showSerName val="0"/>
+            <c:showPercent val="0"/>
+            <c:showBubbleSize val="0"/>
+            <c:showLeaderLines val="0"/>
+          </c:dLbls>
+          <c:cat>
+            <c:multiLvlStrRef>
+              <c:f>Sheet1!$A$2:$A$5</c:f>
+              <c:multiLvlStrCache>
+                <c:ptCount val="4"/>
+                <c:lvl>
+                  <c:pt idx="0">
+                    <c:v>Clean</c:v>
+                  </c:pt>
+                  <c:pt idx="1">
+                    <c:v>Character noise</c:v>
+                  </c:pt>
+                  <c:pt idx="2">
+                    <c:v>Abbreviations</c:v>
+                  </c:pt>
+                  <c:pt idx="3">
+                    <c:v>Telegraphic notes</c:v>
+                  </c:pt>
+                </c:lvl>
+              </c:multiLvlStrCache>
+            </c:multiLvlStrRef>
+          </c:cat>
+          <c:val>
+            <c:numRef>
+              <c:f>Sheet1!$C$2:$C$5</c:f>
+              <c:numCache>
+                <c:formatCode>General</c:formatCode>
+                <c:ptCount val="4"/>
+                <c:pt idx="0">
+                  <c:v>100</c:v>
+                </c:pt>
+                <c:pt idx="1">
+                  <c:v>100</c:v>
+                </c:pt>
+                <c:pt idx="2">
+                  <c:v>100</c:v>
+                </c:pt>
+                <c:pt idx="3">
+                  <c:v>100</c:v>
+                </c:pt>
+              </c:numCache>
+            </c:numRef>
+          </c:val>
+        </c:ser>
+        <c:dLbls>
+          <c:numFmt formatCode="0.0" sourceLinked="0"/>
+          <c:txPr>
+            <a:bodyPr/>
+            <a:lstStyle/>
+            <a:p>
+              <a:pPr>
+                <a:defRPr b="0" i="0" strike="noStrike" sz="1100" u="none">
+                  <a:solidFill>
+                    <a:srgbClr val="12263A"/>
+                  </a:solidFill>
+                  <a:latin typeface="+mn-lt"/>
+                </a:defRPr>
+              </a:pPr>
+            </a:p>
+          </c:txPr>
+          <c:showLegendKey val="0"/>
+          <c:showVal val="1"/>
+          <c:showCatName val="0"/>
+          <c:showSerName val="0"/>
+          <c:showPercent val="0"/>
+          <c:showBubbleSize val="0"/>
+          <c:showLeaderLines val="0"/>
+        </c:dLbls>
+        <c:gapWidth val="55"/>
+        <c:overlap val="0"/>
+        <c:axId val="2094734554"/>
+        <c:axId val="2094734552"/>
+        <c:axId val="2094734556"/>
+      </c:barChart>
+      <c:catAx>
+        <c:axId val="2094734554"/>
+        <c:scaling>
+          <c:orientation val="maxMin"/>
+        </c:scaling>
+        <c:delete val="0"/>
+        <c:axPos val="l"/>
+        <c:numFmt formatCode="General" sourceLinked="1"/>
+        <c:majorTickMark val="out"/>
+        <c:minorTickMark val="none"/>
+        <c:tickLblPos val="nextTo"/>
+        <c:spPr>
+          <a:ln w="12700" cap="flat">
+            <a:solidFill>
+              <a:srgbClr val="888888"/>
+            </a:solidFill>
+            <a:prstDash val="solid"/>
+            <a:round/>
+          </a:ln>
+        </c:spPr>
+        <c:txPr>
+          <a:bodyPr/>
+          <a:lstStyle/>
+          <a:p>
+            <a:pPr>
+              <a:defRPr sz="1200" b="0" i="0" u="none" strike="noStrike">
+                <a:solidFill>
+                  <a:srgbClr val="12263A"/>
+                </a:solidFill>
+                <a:latin typeface="+mn-lt"/>
+              </a:defRPr>
+            </a:pPr>
+            <a:endParaRPr lang="en-US"/>
+          </a:p>
+        </c:txPr>
+        <c:crossAx val="2094734552"/>
+        <c:crosses val="autoZero"/>
+        <c:auto val="1"/>
+        <c:lblAlgn val="ctr"/>
+        <c:noMultiLvlLbl val="1"/>
+      </c:catAx>
+      <c:valAx>
+        <c:axId val="2094734552"/>
+        <c:scaling>
+          <c:orientation val="minMax"/>
+          <c:max val="104"/>
+          <c:min val="80"/>
+        </c:scaling>
+        <c:delete val="1"/>
+        <c:axPos val="b"/>
+        <c:numFmt formatCode="General" sourceLinked="0"/>
+        <c:majorTickMark val="out"/>
+        <c:minorTickMark val="none"/>
+        <c:tickLblPos val="low"/>
+        <c:spPr>
+          <a:ln w="12700" cap="flat">
+            <a:solidFill>
+              <a:srgbClr val="888888"/>
+            </a:solidFill>
+            <a:prstDash val="solid"/>
+            <a:round/>
+          </a:ln>
+        </c:spPr>
+        <c:txPr>
+          <a:bodyPr/>
+          <a:lstStyle/>
+          <a:p>
+            <a:pPr>
+              <a:defRPr sz="1200" b="0" i="0" u="none" strike="noStrike">
+                <a:solidFill>
+                  <a:srgbClr val="000000"/>
+                </a:solidFill>
+                <a:latin typeface="Arial"/>
               </a:defRPr>
             </a:pPr>
             <a:endParaRPr lang="en-US"/>
@@ -1079,7 +1468,7 @@
           <a:p>
             <a:r>
               <a:rPr lang="en-US" dirty="0"/>
-              <a:t>Backup slide. In the live app these are the demo buttons: part payment, rejection, the second-look loop, and the simulated calculation error.</a:t>
+              <a:t>Close, then take questions. Both members should be ready to answer on any slide.</a:t>
             </a:r>
             <a:endParaRPr lang="en-US" dirty="0"/>
           </a:p>
@@ -1167,7 +1556,7 @@
           <a:p>
             <a:r>
               <a:rPr lang="en-US" dirty="0"/>
-              <a:t>Backup slide with the complete architecture: agents, tool belt, data stores, model layer and the feedback loop.</a:t>
+              <a:t>Backup slide. In the live app these are the demo buttons: part payment, rejection, the second-look loop, and the simulated calculation error.</a:t>
             </a:r>
             <a:endParaRPr lang="en-US" dirty="0"/>
           </a:p>
@@ -1191,6 +1580,94 @@
             <a:fld id="{F7021451-1387-4CA6-816F-3879F97B5CBC}" type="slidenum">
               <a:rPr lang="en-US"/>
               <a:t>11</a:t>
+            </a:fld>
+            <a:endParaRPr lang="en-US"/>
+          </a:p>
+        </p:txBody>
+      </p:sp>
+    </p:spTree>
+    <p:extLst>
+      <p:ext uri="{BB962C8B-B14F-4D97-AF65-F5344CB8AC3E}">
+        <p14:creationId xmlns:p14="http://schemas.microsoft.com/office/powerpoint/2010/main" val="1024086991"/>
+      </p:ext>
+    </p:extLst>
+  </p:cSld>
+  <p:clrMapOvr>
+    <a:masterClrMapping/>
+  </p:clrMapOvr>
+</p:notes>
+</file>
+
+<file path=ppt/notesSlides/notesSlide12.xml><?xml version="1.0" encoding="utf-8"?>
+<p:notes xmlns:a="http://schemas.openxmlformats.org/drawingml/2006/main" xmlns:r="http://schemas.openxmlformats.org/officeDocument/2006/relationships" xmlns:p="http://schemas.openxmlformats.org/presentationml/2006/main">
+  <p:cSld>
+    <p:spTree>
+      <p:nvGrpSpPr>
+        <p:cNvPr id="1" name=""/>
+        <p:cNvGrpSpPr/>
+        <p:nvPr/>
+      </p:nvGrpSpPr>
+      <p:grpSpPr>
+        <a:xfrm>
+          <a:off x="0" y="0"/>
+          <a:ext cx="0" cy="0"/>
+          <a:chOff x="0" y="0"/>
+          <a:chExt cx="0" cy="0"/>
+        </a:xfrm>
+      </p:grpSpPr>
+      <p:sp>
+        <p:nvSpPr>
+          <p:cNvPr id="2" name="Slide Image Placeholder 1"/>
+          <p:cNvSpPr>
+            <a:spLocks noGrp="1" noRot="1" noChangeAspect="1"/>
+          </p:cNvSpPr>
+          <p:nvPr>
+            <p:ph type="sldImg"/>
+          </p:nvPr>
+        </p:nvSpPr>
+        <p:spPr/>
+      </p:sp>
+      <p:sp>
+        <p:nvSpPr>
+          <p:cNvPr id="3" name="Notes Placeholder 2"/>
+          <p:cNvSpPr>
+            <a:spLocks noGrp="1"/>
+          </p:cNvSpPr>
+          <p:nvPr>
+            <p:ph type="body" idx="1"/>
+          </p:nvPr>
+        </p:nvSpPr>
+        <p:spPr/>
+        <p:txBody>
+          <a:bodyPr/>
+          <a:lstStyle/>
+          <a:p>
+            <a:r>
+              <a:rPr lang="en-US" dirty="0"/>
+              <a:t>Backup slide with the complete architecture: agents, tool belt, data stores, model layer and the feedback loop.</a:t>
+            </a:r>
+            <a:endParaRPr lang="en-US" dirty="0"/>
+          </a:p>
+        </p:txBody>
+      </p:sp>
+      <p:sp>
+        <p:nvSpPr>
+          <p:cNvPr id="4" name="Slide Number Placeholder 3"/>
+          <p:cNvSpPr>
+            <a:spLocks noGrp="1"/>
+          </p:cNvSpPr>
+          <p:nvPr>
+            <p:ph type="sldNum" sz="quarter" idx="10"/>
+          </p:nvPr>
+        </p:nvSpPr>
+        <p:spPr/>
+        <p:txBody>
+          <a:bodyPr/>
+          <a:lstStyle/>
+          <a:p>
+            <a:fld id="{F7021451-1387-4CA6-816F-3879F97B5CBC}" type="slidenum">
+              <a:rPr lang="en-US"/>
+              <a:t>12</a:t>
             </a:fld>
             <a:endParaRPr lang="en-US"/>
           </a:p>
@@ -1783,7 +2260,7 @@
           <a:p>
             <a:r>
               <a:rPr lang="en-US" dirty="0"/>
-              <a:t>About 30 seconds. Limitations first, because the evaluators will ask. The abbreviation gap is the one we know about and measured. The next step is a language-model extractor, which our pluggable model layer already supports, plus a strict mode that trades more manual reviews for fewer missed pre-existing conditions.</a:t>
+              <a:t>About 50 seconds. Same claims, same rules, two ways of reading the discharge summary. The grey bars are the rules-only parser; the green bars add the local language model. On shorthand like abbreviations and telegraphic notes, the model reads what the parser cannot, and the number of risky claims wrongly paid falls. The third card is the safety check: a model can also invent a condition that is not there and cause a wrongful hold, so we count those too. The model must quote the summary, and we verify the quote, which is what keeps that number low.</a:t>
             </a:r>
             <a:endParaRPr lang="en-US" dirty="0"/>
           </a:p>
@@ -1871,7 +2348,7 @@
           <a:p>
             <a:r>
               <a:rPr lang="en-US" dirty="0"/>
-              <a:t>Close, then take questions. Both members should be ready to answer on any slide.</a:t>
+              <a:t>About 30 seconds. Limitations first, because the evaluators will ask. The abbreviation gap is the one we know about and measured. The next step is a language-model extractor, which our pluggable model layer already supports, plus a strict mode that trades more manual reviews for fewer missed pre-existing conditions.</a:t>
             </a:r>
             <a:endParaRPr lang="en-US" dirty="0"/>
           </a:p>
@@ -3487,8 +3964,8 @@
         </p:nvSpPr>
         <p:spPr>
           <a:xfrm>
-            <a:off x="457200" y="292608"/>
-            <a:ext cx="8229600" cy="777240"/>
+            <a:off x="548640" y="822960"/>
+            <a:ext cx="8046720" cy="822960"/>
           </a:xfrm>
           <a:prstGeom prst="rect">
             <a:avLst/>
@@ -3504,49 +3981,87 @@
               <a:buNone/>
             </a:pPr>
             <a:r>
-              <a:rPr lang="en-US" sz="2800" b="1" dirty="0">
-                <a:solidFill>
-                  <a:schemeClr val="tx1"/>
-                </a:solidFill>
-              </a:rPr>
-              <a:t>Appendix: the four demo claims</a:t>
-            </a:r>
-            <a:endParaRPr lang="en-US" sz="2800" dirty="0"/>
-          </a:p>
-        </p:txBody>
-      </p:sp>
-      <p:sp>
-        <p:nvSpPr>
-          <p:cNvPr id="3" name="Demo card 1"/>
+              <a:rPr lang="en-US" sz="4000" b="1" dirty="0">
+                <a:solidFill>
+                  <a:schemeClr val="bg1"/>
+                </a:solidFill>
+              </a:rPr>
+              <a:t>Thank you</a:t>
+            </a:r>
+            <a:endParaRPr lang="en-US" sz="4000" dirty="0"/>
+          </a:p>
+        </p:txBody>
+      </p:sp>
+      <p:sp>
+        <p:nvSpPr>
+          <p:cNvPr id="3" name="Text 0"/>
           <p:cNvSpPr/>
-          <p:nvPr/>
-        </p:nvSpPr>
-        <p:spPr>
-          <a:xfrm>
-            <a:off x="457200" y="1234440"/>
-            <a:ext cx="4023360" cy="1463040"/>
+          <p:nvPr>
+            <p:ph idx="101" type="body" hasCustomPrompt="1"/>
+          </p:nvPr>
+        </p:nvSpPr>
+        <p:spPr>
+          <a:xfrm>
+            <a:off x="548640" y="1691640"/>
+            <a:ext cx="7498080" cy="731520"/>
+          </a:xfrm>
+          <a:prstGeom prst="rect">
+            <a:avLst/>
+          </a:prstGeom>
+          <a:noFill/>
+          <a:ln/>
+        </p:spPr>
+        <p:txBody>
+          <a:bodyPr wrap="square" lIns="0" tIns="0" rIns="0" bIns="0" rtlCol="0" anchor="t"/>
+          <a:lstStyle/>
+          <a:p>
+            <a:pPr algn="l" indent="0" marL="0">
+              <a:buNone/>
+            </a:pPr>
+            <a:r>
+              <a:rPr lang="en-US" sz="1800" dirty="0">
+                <a:solidFill>
+                  <a:schemeClr val="bg2"/>
+                </a:solidFill>
+              </a:rPr>
+              <a:t>Questions welcome</a:t>
+            </a:r>
+            <a:endParaRPr lang="en-US" sz="1800" dirty="0"/>
+          </a:p>
+        </p:txBody>
+      </p:sp>
+      <p:sp>
+        <p:nvSpPr>
+          <p:cNvPr id="4" name="Closing members card"/>
+          <p:cNvSpPr/>
+          <p:nvPr/>
+        </p:nvSpPr>
+        <p:spPr>
+          <a:xfrm>
+            <a:off x="548640" y="2651760"/>
+            <a:ext cx="8046720" cy="1051560"/>
           </a:xfrm>
           <a:prstGeom prst="roundRect">
             <a:avLst>
-              <a:gd name="adj" fmla="val 5000"/>
+              <a:gd name="adj" fmla="val 6957"/>
             </a:avLst>
           </a:prstGeom>
           <a:solidFill>
-            <a:schemeClr val="bg2"/>
+            <a:schemeClr val="tx2"/>
           </a:solidFill>
           <a:ln/>
         </p:spPr>
       </p:sp>
       <p:sp>
         <p:nvSpPr>
-          <p:cNvPr id="4" name="Demo id 1"/>
-          <p:cNvSpPr txBox="1"/>
-          <p:nvPr/>
-        </p:nvSpPr>
-        <p:spPr>
-          <a:xfrm>
-            <a:off x="640080" y="1371600"/>
-            <a:ext cx="2377440" cy="274320"/>
+          <p:cNvPr id="5" name="Closing label"/>
+          <p:cNvSpPr txBox="1"/>
+          <p:nvPr/>
+        </p:nvSpPr>
+        <p:spPr>
+          <a:xfrm>
+            <a:off x="822960" y="2743200"/>
+            <a:ext cx="2743200" cy="228600"/>
           </a:xfrm>
           <a:prstGeom prst="rect">
             <a:avLst/>
@@ -3562,85 +4077,66 @@
               <a:buNone/>
             </a:pPr>
             <a:r>
-              <a:rPr lang="en-US" sz="1200" b="1" dirty="0">
-                <a:solidFill>
-                  <a:schemeClr val="tx2"/>
-                </a:solidFill>
-              </a:rPr>
-              <a:t>CLM-26-0001</a:t>
-            </a:r>
-            <a:endParaRPr lang="en-US" sz="1200" dirty="0"/>
-          </a:p>
-        </p:txBody>
-      </p:sp>
-      <p:sp>
-        <p:nvSpPr>
-          <p:cNvPr id="5" name="Demo outcome 1"/>
-          <p:cNvSpPr/>
-          <p:nvPr/>
-        </p:nvSpPr>
-        <p:spPr>
-          <a:xfrm>
-            <a:off x="3246120" y="1353312"/>
-            <a:ext cx="1051560" cy="292608"/>
-          </a:xfrm>
-          <a:prstGeom prst="roundRect">
-            <a:avLst>
-              <a:gd name="adj" fmla="val 50000"/>
-            </a:avLst>
-          </a:prstGeom>
-          <a:solidFill>
-            <a:schemeClr val="accent6"/>
-          </a:solidFill>
-          <a:ln/>
-        </p:spPr>
-      </p:sp>
-      <p:sp>
-        <p:nvSpPr>
-          <p:cNvPr id="6" name="Demo outcome label 1"/>
-          <p:cNvSpPr txBox="1"/>
-          <p:nvPr/>
-        </p:nvSpPr>
-        <p:spPr>
-          <a:xfrm>
-            <a:off x="3246120" y="1353312"/>
-            <a:ext cx="1051560" cy="292608"/>
-          </a:xfrm>
-          <a:prstGeom prst="rect">
-            <a:avLst/>
-          </a:prstGeom>
-          <a:noFill/>
-          <a:ln/>
-        </p:spPr>
-        <p:txBody>
-          <a:bodyPr wrap="square" lIns="0" tIns="0" rIns="0" bIns="0" rtlCol="0" anchor="ctr"/>
-          <a:lstStyle/>
-          <a:p>
-            <a:pPr algn="ctr" indent="0" marL="0">
-              <a:buNone/>
-            </a:pPr>
-            <a:r>
-              <a:rPr lang="en-US" sz="1100" b="1" dirty="0">
+              <a:rPr lang="en-US" sz="1100" b="1" spc="300" kern="0" dirty="0">
+                <a:solidFill>
+                  <a:schemeClr val="bg2"/>
+                </a:solidFill>
+              </a:rPr>
+              <a:t>GROUP MEMBERS</a:t>
+            </a:r>
+            <a:endParaRPr lang="en-US" sz="1100" dirty="0"/>
+          </a:p>
+        </p:txBody>
+      </p:sp>
+      <p:sp>
+        <p:nvSpPr>
+          <p:cNvPr id="6" name="Closing name 1"/>
+          <p:cNvSpPr txBox="1"/>
+          <p:nvPr/>
+        </p:nvSpPr>
+        <p:spPr>
+          <a:xfrm>
+            <a:off x="822960" y="3035808"/>
+            <a:ext cx="3017520" cy="365760"/>
+          </a:xfrm>
+          <a:prstGeom prst="rect">
+            <a:avLst/>
+          </a:prstGeom>
+          <a:noFill/>
+          <a:ln/>
+        </p:spPr>
+        <p:txBody>
+          <a:bodyPr wrap="square" lIns="0" tIns="0" rIns="0" bIns="0" rtlCol="0" anchor="t"/>
+          <a:lstStyle/>
+          <a:p>
+            <a:pPr indent="0" marL="0">
+              <a:buNone/>
+            </a:pPr>
+            <a:r>
+              <a:rPr lang="en-US" sz="2000" b="1" dirty="0">
                 <a:solidFill>
                   <a:schemeClr val="bg1"/>
                 </a:solidFill>
-              </a:rPr>
-              <a:t>PARTIAL</a:t>
-            </a:r>
-            <a:endParaRPr lang="en-US" sz="1100" dirty="0"/>
-          </a:p>
-        </p:txBody>
-      </p:sp>
-      <p:sp>
-        <p:nvSpPr>
-          <p:cNvPr id="7" name="Demo headline 1"/>
-          <p:cNvSpPr txBox="1"/>
-          <p:nvPr/>
-        </p:nvSpPr>
-        <p:spPr>
-          <a:xfrm>
-            <a:off x="640080" y="1737360"/>
-            <a:ext cx="3657600" cy="502920"/>
+                <a:latin typeface="Cambria" pitchFamily="34" charset="0"/>
+                <a:ea typeface="Cambria" pitchFamily="34" charset="-122"/>
+                <a:cs typeface="Cambria" pitchFamily="34" charset="-120"/>
+              </a:rPr>
+              <a:t>Harsh Salunkhe</a:t>
+            </a:r>
+            <a:endParaRPr lang="en-US" sz="2000" dirty="0"/>
+          </a:p>
+        </p:txBody>
+      </p:sp>
+      <p:sp>
+        <p:nvSpPr>
+          <p:cNvPr id="7" name="Closing roll 1"/>
+          <p:cNvSpPr txBox="1"/>
+          <p:nvPr/>
+        </p:nvSpPr>
+        <p:spPr>
+          <a:xfrm>
+            <a:off x="822960" y="3419856"/>
+            <a:ext cx="3017520" cy="274320"/>
           </a:xfrm>
           <a:prstGeom prst="rect">
             <a:avLst/>
@@ -3656,27 +4152,27 @@
               <a:buNone/>
             </a:pPr>
             <a:r>
-              <a:rPr lang="en-US" sz="1600" b="1" dirty="0">
-                <a:solidFill>
-                  <a:schemeClr val="tx1"/>
-                </a:solidFill>
-              </a:rPr>
-              <a:t>Room rent above the plan cap</a:t>
-            </a:r>
-            <a:endParaRPr lang="en-US" sz="1600" dirty="0"/>
-          </a:p>
-        </p:txBody>
-      </p:sp>
-      <p:sp>
-        <p:nvSpPr>
-          <p:cNvPr id="8" name="Demo detail 1"/>
-          <p:cNvSpPr txBox="1"/>
-          <p:nvPr/>
-        </p:nvSpPr>
-        <p:spPr>
-          <a:xfrm>
-            <a:off x="640080" y="2240280"/>
-            <a:ext cx="3657600" cy="365760"/>
+              <a:rPr lang="en-US" sz="1400" dirty="0">
+                <a:solidFill>
+                  <a:schemeClr val="bg2"/>
+                </a:solidFill>
+              </a:rPr>
+              <a:t>24070126066</a:t>
+            </a:r>
+            <a:endParaRPr lang="en-US" sz="1400" dirty="0"/>
+          </a:p>
+        </p:txBody>
+      </p:sp>
+      <p:sp>
+        <p:nvSpPr>
+          <p:cNvPr id="8" name="Closing name 2"/>
+          <p:cNvSpPr txBox="1"/>
+          <p:nvPr/>
+        </p:nvSpPr>
+        <p:spPr>
+          <a:xfrm>
+            <a:off x="4023360" y="3035808"/>
+            <a:ext cx="3017520" cy="365760"/>
           </a:xfrm>
           <a:prstGeom prst="rect">
             <a:avLst/>
@@ -3692,49 +4188,30 @@
               <a:buNone/>
             </a:pPr>
             <a:r>
-              <a:rPr lang="en-US" sz="1300" dirty="0">
-                <a:solidFill>
-                  <a:schemeClr val="tx2"/>
-                </a:solidFill>
-              </a:rPr>
-              <a:t>Proportionate deduction, clause C6</a:t>
-            </a:r>
-            <a:endParaRPr lang="en-US" sz="1300" dirty="0"/>
-          </a:p>
-        </p:txBody>
-      </p:sp>
-      <p:sp>
-        <p:nvSpPr>
-          <p:cNvPr id="9" name="Demo card 2"/>
-          <p:cNvSpPr/>
-          <p:nvPr/>
-        </p:nvSpPr>
-        <p:spPr>
-          <a:xfrm>
-            <a:off x="4663440" y="1234440"/>
-            <a:ext cx="4023360" cy="1463040"/>
-          </a:xfrm>
-          <a:prstGeom prst="roundRect">
-            <a:avLst>
-              <a:gd name="adj" fmla="val 5000"/>
-            </a:avLst>
-          </a:prstGeom>
-          <a:solidFill>
-            <a:schemeClr val="bg2"/>
-          </a:solidFill>
-          <a:ln/>
-        </p:spPr>
-      </p:sp>
-      <p:sp>
-        <p:nvSpPr>
-          <p:cNvPr id="10" name="Demo id 2"/>
-          <p:cNvSpPr txBox="1"/>
-          <p:nvPr/>
-        </p:nvSpPr>
-        <p:spPr>
-          <a:xfrm>
-            <a:off x="4846320" y="1371600"/>
-            <a:ext cx="2377440" cy="274320"/>
+              <a:rPr lang="en-US" sz="2000" b="1" dirty="0">
+                <a:solidFill>
+                  <a:schemeClr val="bg1"/>
+                </a:solidFill>
+                <a:latin typeface="Cambria" pitchFamily="34" charset="0"/>
+                <a:ea typeface="Cambria" pitchFamily="34" charset="-122"/>
+                <a:cs typeface="Cambria" pitchFamily="34" charset="-120"/>
+              </a:rPr>
+              <a:t>Dharna Sharma</a:t>
+            </a:r>
+            <a:endParaRPr lang="en-US" sz="2000" dirty="0"/>
+          </a:p>
+        </p:txBody>
+      </p:sp>
+      <p:sp>
+        <p:nvSpPr>
+          <p:cNvPr id="9" name="Closing roll 2"/>
+          <p:cNvSpPr txBox="1"/>
+          <p:nvPr/>
+        </p:nvSpPr>
+        <p:spPr>
+          <a:xfrm>
+            <a:off x="4023360" y="3419856"/>
+            <a:ext cx="3017520" cy="274320"/>
           </a:xfrm>
           <a:prstGeom prst="rect">
             <a:avLst/>
@@ -3750,85 +4227,27 @@
               <a:buNone/>
             </a:pPr>
             <a:r>
-              <a:rPr lang="en-US" sz="1200" b="1" dirty="0">
-                <a:solidFill>
-                  <a:schemeClr val="tx2"/>
-                </a:solidFill>
-              </a:rPr>
-              <a:t>CLM-26-0007</a:t>
-            </a:r>
-            <a:endParaRPr lang="en-US" sz="1200" dirty="0"/>
-          </a:p>
-        </p:txBody>
-      </p:sp>
-      <p:sp>
-        <p:nvSpPr>
-          <p:cNvPr id="11" name="Demo outcome 2"/>
-          <p:cNvSpPr/>
-          <p:nvPr/>
-        </p:nvSpPr>
-        <p:spPr>
-          <a:xfrm>
-            <a:off x="7452360" y="1353312"/>
-            <a:ext cx="1051560" cy="292608"/>
-          </a:xfrm>
-          <a:prstGeom prst="roundRect">
-            <a:avLst>
-              <a:gd name="adj" fmla="val 50000"/>
-            </a:avLst>
-          </a:prstGeom>
-          <a:solidFill>
-            <a:schemeClr val="accent5"/>
-          </a:solidFill>
-          <a:ln/>
-        </p:spPr>
-      </p:sp>
-      <p:sp>
-        <p:nvSpPr>
-          <p:cNvPr id="12" name="Demo outcome label 2"/>
-          <p:cNvSpPr txBox="1"/>
-          <p:nvPr/>
-        </p:nvSpPr>
-        <p:spPr>
-          <a:xfrm>
-            <a:off x="7452360" y="1353312"/>
-            <a:ext cx="1051560" cy="292608"/>
-          </a:xfrm>
-          <a:prstGeom prst="rect">
-            <a:avLst/>
-          </a:prstGeom>
-          <a:noFill/>
-          <a:ln/>
-        </p:spPr>
-        <p:txBody>
-          <a:bodyPr wrap="square" lIns="0" tIns="0" rIns="0" bIns="0" rtlCol="0" anchor="ctr"/>
-          <a:lstStyle/>
-          <a:p>
-            <a:pPr algn="ctr" indent="0" marL="0">
-              <a:buNone/>
-            </a:pPr>
-            <a:r>
-              <a:rPr lang="en-US" sz="1100" b="1" dirty="0">
-                <a:solidFill>
-                  <a:schemeClr val="bg1"/>
-                </a:solidFill>
-              </a:rPr>
-              <a:t>REJECT</a:t>
-            </a:r>
-            <a:endParaRPr lang="en-US" sz="1100" dirty="0"/>
-          </a:p>
-        </p:txBody>
-      </p:sp>
-      <p:sp>
-        <p:nvSpPr>
-          <p:cNvPr id="13" name="Demo headline 2"/>
-          <p:cNvSpPr txBox="1"/>
-          <p:nvPr/>
-        </p:nvSpPr>
-        <p:spPr>
-          <a:xfrm>
-            <a:off x="4846320" y="1737360"/>
-            <a:ext cx="3657600" cy="502920"/>
+              <a:rPr lang="en-US" sz="1400" dirty="0">
+                <a:solidFill>
+                  <a:schemeClr val="bg2"/>
+                </a:solidFill>
+              </a:rPr>
+              <a:t>24070126053</a:t>
+            </a:r>
+            <a:endParaRPr lang="en-US" sz="1400" dirty="0"/>
+          </a:p>
+        </p:txBody>
+      </p:sp>
+      <p:sp>
+        <p:nvSpPr>
+          <p:cNvPr id="10" name="Repo link"/>
+          <p:cNvSpPr txBox="1"/>
+          <p:nvPr/>
+        </p:nvSpPr>
+        <p:spPr>
+          <a:xfrm>
+            <a:off x="548640" y="3977640"/>
+            <a:ext cx="8046720" cy="274320"/>
           </a:xfrm>
           <a:prstGeom prst="rect">
             <a:avLst/>
@@ -3844,27 +4263,27 @@
               <a:buNone/>
             </a:pPr>
             <a:r>
-              <a:rPr lang="en-US" sz="1600" b="1" dirty="0">
-                <a:solidFill>
-                  <a:schemeClr val="tx1"/>
-                </a:solidFill>
-              </a:rPr>
-              <a:t>Pre-existing condition inside 24 months</a:t>
-            </a:r>
-            <a:endParaRPr lang="en-US" sz="1600" dirty="0"/>
-          </a:p>
-        </p:txBody>
-      </p:sp>
-      <p:sp>
-        <p:nvSpPr>
-          <p:cNvPr id="14" name="Demo detail 2"/>
-          <p:cNvSpPr txBox="1"/>
-          <p:nvPr/>
-        </p:nvSpPr>
-        <p:spPr>
-          <a:xfrm>
-            <a:off x="4846320" y="2240280"/>
-            <a:ext cx="3657600" cy="365760"/>
+              <a:rPr lang="en-US" sz="1400" dirty="0">
+                <a:solidFill>
+                  <a:schemeClr val="bg2"/>
+                </a:solidFill>
+              </a:rPr>
+              <a:t>Code: github.com/HarshSalunkhe2005/claims-adjudication-agent  (full code also submitted as a zip)</a:t>
+            </a:r>
+            <a:endParaRPr lang="en-US" sz="1400" dirty="0"/>
+          </a:p>
+        </p:txBody>
+      </p:sp>
+      <p:sp>
+        <p:nvSpPr>
+          <p:cNvPr id="11" name="Local note"/>
+          <p:cNvSpPr txBox="1"/>
+          <p:nvPr/>
+        </p:nvSpPr>
+        <p:spPr>
+          <a:xfrm>
+            <a:off x="548640" y="4343400"/>
+            <a:ext cx="8046720" cy="274320"/>
           </a:xfrm>
           <a:prstGeom prst="rect">
             <a:avLst/>
@@ -3880,435 +4299,14 @@
               <a:buNone/>
             </a:pPr>
             <a:r>
-              <a:rPr lang="en-US" sz="1300" dirty="0">
-                <a:solidFill>
-                  <a:schemeClr val="tx2"/>
-                </a:solidFill>
-              </a:rPr>
-              <a:t>Early exit, remaining checks skipped, clause C3</a:t>
-            </a:r>
-            <a:endParaRPr lang="en-US" sz="1300" dirty="0"/>
-          </a:p>
-        </p:txBody>
-      </p:sp>
-      <p:sp>
-        <p:nvSpPr>
-          <p:cNvPr id="15" name="Demo card 3"/>
-          <p:cNvSpPr/>
-          <p:nvPr/>
-        </p:nvSpPr>
-        <p:spPr>
-          <a:xfrm>
-            <a:off x="457200" y="2880360"/>
-            <a:ext cx="4023360" cy="1463040"/>
-          </a:xfrm>
-          <a:prstGeom prst="roundRect">
-            <a:avLst>
-              <a:gd name="adj" fmla="val 5000"/>
-            </a:avLst>
-          </a:prstGeom>
-          <a:solidFill>
-            <a:schemeClr val="bg2"/>
-          </a:solidFill>
-          <a:ln/>
-        </p:spPr>
-      </p:sp>
-      <p:sp>
-        <p:nvSpPr>
-          <p:cNvPr id="16" name="Demo id 3"/>
-          <p:cNvSpPr txBox="1"/>
-          <p:nvPr/>
-        </p:nvSpPr>
-        <p:spPr>
-          <a:xfrm>
-            <a:off x="640080" y="3017520"/>
-            <a:ext cx="2377440" cy="274320"/>
-          </a:xfrm>
-          <a:prstGeom prst="rect">
-            <a:avLst/>
-          </a:prstGeom>
-          <a:noFill/>
-          <a:ln/>
-        </p:spPr>
-        <p:txBody>
-          <a:bodyPr wrap="square" lIns="0" tIns="0" rIns="0" bIns="0" rtlCol="0" anchor="t"/>
-          <a:lstStyle/>
-          <a:p>
-            <a:pPr indent="0" marL="0">
-              <a:buNone/>
-            </a:pPr>
-            <a:r>
-              <a:rPr lang="en-US" sz="1200" b="1" dirty="0">
-                <a:solidFill>
-                  <a:schemeClr val="tx2"/>
-                </a:solidFill>
-              </a:rPr>
-              <a:t>CLM-26-0019</a:t>
-            </a:r>
-            <a:endParaRPr lang="en-US" sz="1200" dirty="0"/>
-          </a:p>
-        </p:txBody>
-      </p:sp>
-      <p:sp>
-        <p:nvSpPr>
-          <p:cNvPr id="17" name="Demo outcome 3"/>
-          <p:cNvSpPr/>
-          <p:nvPr/>
-        </p:nvSpPr>
-        <p:spPr>
-          <a:xfrm>
-            <a:off x="3246120" y="2999232"/>
-            <a:ext cx="1051560" cy="292608"/>
-          </a:xfrm>
-          <a:prstGeom prst="roundRect">
-            <a:avLst>
-              <a:gd name="adj" fmla="val 50000"/>
-            </a:avLst>
-          </a:prstGeom>
-          <a:solidFill>
-            <a:schemeClr val="accent2"/>
-          </a:solidFill>
-          <a:ln/>
-        </p:spPr>
-      </p:sp>
-      <p:sp>
-        <p:nvSpPr>
-          <p:cNvPr id="18" name="Demo outcome label 3"/>
-          <p:cNvSpPr txBox="1"/>
-          <p:nvPr/>
-        </p:nvSpPr>
-        <p:spPr>
-          <a:xfrm>
-            <a:off x="3246120" y="2999232"/>
-            <a:ext cx="1051560" cy="292608"/>
-          </a:xfrm>
-          <a:prstGeom prst="rect">
-            <a:avLst/>
-          </a:prstGeom>
-          <a:noFill/>
-          <a:ln/>
-        </p:spPr>
-        <p:txBody>
-          <a:bodyPr wrap="square" lIns="0" tIns="0" rIns="0" bIns="0" rtlCol="0" anchor="ctr"/>
-          <a:lstStyle/>
-          <a:p>
-            <a:pPr algn="ctr" indent="0" marL="0">
-              <a:buNone/>
-            </a:pPr>
-            <a:r>
-              <a:rPr lang="en-US" sz="1100" b="1" dirty="0">
-                <a:solidFill>
-                  <a:schemeClr val="bg1"/>
-                </a:solidFill>
-              </a:rPr>
-              <a:t>ESCALATE</a:t>
-            </a:r>
-            <a:endParaRPr lang="en-US" sz="1100" dirty="0"/>
-          </a:p>
-        </p:txBody>
-      </p:sp>
-      <p:sp>
-        <p:nvSpPr>
-          <p:cNvPr id="19" name="Demo headline 3"/>
-          <p:cNvSpPr txBox="1"/>
-          <p:nvPr/>
-        </p:nvSpPr>
-        <p:spPr>
-          <a:xfrm>
-            <a:off x="640080" y="3383280"/>
-            <a:ext cx="3657600" cy="502920"/>
-          </a:xfrm>
-          <a:prstGeom prst="rect">
-            <a:avLst/>
-          </a:prstGeom>
-          <a:noFill/>
-          <a:ln/>
-        </p:spPr>
-        <p:txBody>
-          <a:bodyPr wrap="square" lIns="0" tIns="0" rIns="0" bIns="0" rtlCol="0" anchor="t"/>
-          <a:lstStyle/>
-          <a:p>
-            <a:pPr indent="0" marL="0">
-              <a:buNone/>
-            </a:pPr>
-            <a:r>
-              <a:rPr lang="en-US" sz="1600" b="1" dirty="0">
-                <a:solidFill>
-                  <a:schemeClr val="tx1"/>
-                </a:solidFill>
-              </a:rPr>
-              <a:t>Quick plan misses an inflated bill</a:t>
-            </a:r>
-            <a:endParaRPr lang="en-US" sz="1600" dirty="0"/>
-          </a:p>
-        </p:txBody>
-      </p:sp>
-      <p:sp>
-        <p:nvSpPr>
-          <p:cNvPr id="20" name="Demo detail 3"/>
-          <p:cNvSpPr txBox="1"/>
-          <p:nvPr/>
-        </p:nvSpPr>
-        <p:spPr>
-          <a:xfrm>
-            <a:off x="640080" y="3886200"/>
-            <a:ext cx="3657600" cy="365760"/>
-          </a:xfrm>
-          <a:prstGeom prst="rect">
-            <a:avLst/>
-          </a:prstGeom>
-          <a:noFill/>
-          <a:ln/>
-        </p:spPr>
-        <p:txBody>
-          <a:bodyPr wrap="square" lIns="0" tIns="0" rIns="0" bIns="0" rtlCol="0" anchor="t"/>
-          <a:lstStyle/>
-          <a:p>
-            <a:pPr indent="0" marL="0">
-              <a:buNone/>
-            </a:pPr>
-            <a:r>
-              <a:rPr lang="en-US" sz="1300" dirty="0">
-                <a:solidFill>
-                  <a:schemeClr val="tx2"/>
-                </a:solidFill>
-              </a:rPr>
-              <a:t>Critic sends it back, fraud score, human review</a:t>
-            </a:r>
-            <a:endParaRPr lang="en-US" sz="1300" dirty="0"/>
-          </a:p>
-        </p:txBody>
-      </p:sp>
-      <p:sp>
-        <p:nvSpPr>
-          <p:cNvPr id="21" name="Demo card 4"/>
-          <p:cNvSpPr/>
-          <p:nvPr/>
-        </p:nvSpPr>
-        <p:spPr>
-          <a:xfrm>
-            <a:off x="4663440" y="2880360"/>
-            <a:ext cx="4023360" cy="1463040"/>
-          </a:xfrm>
-          <a:prstGeom prst="roundRect">
-            <a:avLst>
-              <a:gd name="adj" fmla="val 5000"/>
-            </a:avLst>
-          </a:prstGeom>
-          <a:solidFill>
-            <a:schemeClr val="bg2"/>
-          </a:solidFill>
-          <a:ln/>
-        </p:spPr>
-      </p:sp>
-      <p:sp>
-        <p:nvSpPr>
-          <p:cNvPr id="22" name="Demo id 4"/>
-          <p:cNvSpPr txBox="1"/>
-          <p:nvPr/>
-        </p:nvSpPr>
-        <p:spPr>
-          <a:xfrm>
-            <a:off x="4846320" y="3017520"/>
-            <a:ext cx="2377440" cy="274320"/>
-          </a:xfrm>
-          <a:prstGeom prst="rect">
-            <a:avLst/>
-          </a:prstGeom>
-          <a:noFill/>
-          <a:ln/>
-        </p:spPr>
-        <p:txBody>
-          <a:bodyPr wrap="square" lIns="0" tIns="0" rIns="0" bIns="0" rtlCol="0" anchor="t"/>
-          <a:lstStyle/>
-          <a:p>
-            <a:pPr indent="0" marL="0">
-              <a:buNone/>
-            </a:pPr>
-            <a:r>
-              <a:rPr lang="en-US" sz="1200" b="1" dirty="0">
-                <a:solidFill>
-                  <a:schemeClr val="tx2"/>
-                </a:solidFill>
-              </a:rPr>
-              <a:t>CLM-26-0003 + error</a:t>
-            </a:r>
-            <a:endParaRPr lang="en-US" sz="1200" dirty="0"/>
-          </a:p>
-        </p:txBody>
-      </p:sp>
-      <p:sp>
-        <p:nvSpPr>
-          <p:cNvPr id="23" name="Demo outcome 4"/>
-          <p:cNvSpPr/>
-          <p:nvPr/>
-        </p:nvSpPr>
-        <p:spPr>
-          <a:xfrm>
-            <a:off x="7452360" y="2999232"/>
-            <a:ext cx="1051560" cy="292608"/>
-          </a:xfrm>
-          <a:prstGeom prst="roundRect">
-            <a:avLst>
-              <a:gd name="adj" fmla="val 50000"/>
-            </a:avLst>
-          </a:prstGeom>
-          <a:solidFill>
-            <a:schemeClr val="accent4"/>
-          </a:solidFill>
-          <a:ln/>
-        </p:spPr>
-      </p:sp>
-      <p:sp>
-        <p:nvSpPr>
-          <p:cNvPr id="24" name="Demo outcome label 4"/>
-          <p:cNvSpPr txBox="1"/>
-          <p:nvPr/>
-        </p:nvSpPr>
-        <p:spPr>
-          <a:xfrm>
-            <a:off x="7452360" y="2999232"/>
-            <a:ext cx="1051560" cy="292608"/>
-          </a:xfrm>
-          <a:prstGeom prst="rect">
-            <a:avLst/>
-          </a:prstGeom>
-          <a:noFill/>
-          <a:ln/>
-        </p:spPr>
-        <p:txBody>
-          <a:bodyPr wrap="square" lIns="0" tIns="0" rIns="0" bIns="0" rtlCol="0" anchor="ctr"/>
-          <a:lstStyle/>
-          <a:p>
-            <a:pPr algn="ctr" indent="0" marL="0">
-              <a:buNone/>
-            </a:pPr>
-            <a:r>
-              <a:rPr lang="en-US" sz="1100" b="1" dirty="0">
-                <a:solidFill>
-                  <a:schemeClr val="bg1"/>
-                </a:solidFill>
-              </a:rPr>
-              <a:t>APPROVE</a:t>
-            </a:r>
-            <a:endParaRPr lang="en-US" sz="1100" dirty="0"/>
-          </a:p>
-        </p:txBody>
-      </p:sp>
-      <p:sp>
-        <p:nvSpPr>
-          <p:cNvPr id="25" name="Demo headline 4"/>
-          <p:cNvSpPr txBox="1"/>
-          <p:nvPr/>
-        </p:nvSpPr>
-        <p:spPr>
-          <a:xfrm>
-            <a:off x="4846320" y="3383280"/>
-            <a:ext cx="3657600" cy="502920"/>
-          </a:xfrm>
-          <a:prstGeom prst="rect">
-            <a:avLst/>
-          </a:prstGeom>
-          <a:noFill/>
-          <a:ln/>
-        </p:spPr>
-        <p:txBody>
-          <a:bodyPr wrap="square" lIns="0" tIns="0" rIns="0" bIns="0" rtlCol="0" anchor="t"/>
-          <a:lstStyle/>
-          <a:p>
-            <a:pPr indent="0" marL="0">
-              <a:buNone/>
-            </a:pPr>
-            <a:r>
-              <a:rPr lang="en-US" sz="1600" b="1" dirty="0">
-                <a:solidFill>
-                  <a:schemeClr val="tx1"/>
-                </a:solidFill>
-              </a:rPr>
-              <a:t>Executor overpays by 15% on purpose</a:t>
-            </a:r>
-            <a:endParaRPr lang="en-US" sz="1600" dirty="0"/>
-          </a:p>
-        </p:txBody>
-      </p:sp>
-      <p:sp>
-        <p:nvSpPr>
-          <p:cNvPr id="26" name="Demo detail 4"/>
-          <p:cNvSpPr txBox="1"/>
-          <p:nvPr/>
-        </p:nvSpPr>
-        <p:spPr>
-          <a:xfrm>
-            <a:off x="4846320" y="3886200"/>
-            <a:ext cx="3657600" cy="365760"/>
-          </a:xfrm>
-          <a:prstGeom prst="rect">
-            <a:avLst/>
-          </a:prstGeom>
-          <a:noFill/>
-          <a:ln/>
-        </p:spPr>
-        <p:txBody>
-          <a:bodyPr wrap="square" lIns="0" tIns="0" rIns="0" bIns="0" rtlCol="0" anchor="t"/>
-          <a:lstStyle/>
-          <a:p>
-            <a:pPr indent="0" marL="0">
-              <a:buNone/>
-            </a:pPr>
-            <a:r>
-              <a:rPr lang="en-US" sz="1300" dirty="0">
-                <a:solidFill>
-                  <a:schemeClr val="tx2"/>
-                </a:solidFill>
-              </a:rPr>
-              <a:t>Critic catches it, recomputes, passes</a:t>
-            </a:r>
-            <a:endParaRPr lang="en-US" sz="1300" dirty="0"/>
-          </a:p>
-        </p:txBody>
-      </p:sp>
-      <p:sp>
-        <p:nvSpPr>
-          <p:cNvPr id="25" name="Slide Number Placeholder 0"/>
-          <p:cNvSpPr>
-            <a:spLocks noGrp="1"/>
-          </p:cNvSpPr>
-          <p:nvPr>
-            <p:ph type="sldNum" sz="quarter" idx="4294967295"/>
-          </p:nvPr>
-        </p:nvSpPr>
-        <p:spPr>
-          <a:xfrm>
-            <a:off x="8321040" y="4773168"/>
-            <a:ext cx="457200" cy="228600"/>
-          </a:xfrm>
-          <a:prstGeom prst="rect">
-            <a:avLst/>
-          </a:prstGeom>
-          <a:extLst>
-            <a:ext uri="{C572A759-6A51-4108-AA02-DFA0A04FC94B}">
-              <ma14:wrappingTextBoxFlag xmlns:ma14="http://schemas.microsoft.com/office/mac/drawingml/2011/main" val="0"/>
-            </a:ext>
-          </a:extLst>
-        </p:spPr>
-        <p:txBody>
-          <a:bodyPr/>
-          <a:lstStyle>
-            <a:lvl1pPr>
-              <a:defRPr sz="1000">
-                <a:solidFill>
-                  <a:schemeClr val="tx2"/>
-                </a:solidFill>
-              </a:defRPr>
-            </a:lvl1pPr>
-          </a:lstStyle>
-          <a:p>
-            <a:pPr algn="r"/>
-            <a:fld id="{F7021451-1387-4CA6-816F-3879F97B5CBC}" type="slidenum">
-              <a:rPr b="0" lang="en-US"/>
-              <a:t>10</a:t>
-            </a:fld>
-            <a:endParaRPr lang="en-US"/>
+              <a:rPr lang="en-US" sz="1400" dirty="0">
+                <a:solidFill>
+                  <a:schemeClr val="bg2"/>
+                </a:solidFill>
+              </a:rPr>
+              <a:t>Runs on a laptop: local language model through Ollama, no cloud services</a:t>
+            </a:r>
+            <a:endParaRPr lang="en-US" sz="1400" dirty="0"/>
           </a:p>
         </p:txBody>
       </p:sp>
@@ -4369,6 +4367,866 @@
                   <a:schemeClr val="tx1"/>
                 </a:solidFill>
               </a:rPr>
+              <a:t>Appendix: the four demo claims</a:t>
+            </a:r>
+            <a:endParaRPr lang="en-US" sz="2800" dirty="0"/>
+          </a:p>
+        </p:txBody>
+      </p:sp>
+      <p:sp>
+        <p:nvSpPr>
+          <p:cNvPr id="3" name="Demo card 1"/>
+          <p:cNvSpPr/>
+          <p:nvPr/>
+        </p:nvSpPr>
+        <p:spPr>
+          <a:xfrm>
+            <a:off x="457200" y="1234440"/>
+            <a:ext cx="4023360" cy="1463040"/>
+          </a:xfrm>
+          <a:prstGeom prst="roundRect">
+            <a:avLst>
+              <a:gd name="adj" fmla="val 5000"/>
+            </a:avLst>
+          </a:prstGeom>
+          <a:solidFill>
+            <a:schemeClr val="bg2"/>
+          </a:solidFill>
+          <a:ln/>
+        </p:spPr>
+      </p:sp>
+      <p:sp>
+        <p:nvSpPr>
+          <p:cNvPr id="4" name="Demo id 1"/>
+          <p:cNvSpPr txBox="1"/>
+          <p:nvPr/>
+        </p:nvSpPr>
+        <p:spPr>
+          <a:xfrm>
+            <a:off x="640080" y="1371600"/>
+            <a:ext cx="2377440" cy="274320"/>
+          </a:xfrm>
+          <a:prstGeom prst="rect">
+            <a:avLst/>
+          </a:prstGeom>
+          <a:noFill/>
+          <a:ln/>
+        </p:spPr>
+        <p:txBody>
+          <a:bodyPr wrap="square" lIns="0" tIns="0" rIns="0" bIns="0" rtlCol="0" anchor="t"/>
+          <a:lstStyle/>
+          <a:p>
+            <a:pPr indent="0" marL="0">
+              <a:buNone/>
+            </a:pPr>
+            <a:r>
+              <a:rPr lang="en-US" sz="1200" b="1" dirty="0">
+                <a:solidFill>
+                  <a:schemeClr val="tx2"/>
+                </a:solidFill>
+              </a:rPr>
+              <a:t>CLM-26-0001</a:t>
+            </a:r>
+            <a:endParaRPr lang="en-US" sz="1200" dirty="0"/>
+          </a:p>
+        </p:txBody>
+      </p:sp>
+      <p:sp>
+        <p:nvSpPr>
+          <p:cNvPr id="5" name="Demo outcome 1"/>
+          <p:cNvSpPr/>
+          <p:nvPr/>
+        </p:nvSpPr>
+        <p:spPr>
+          <a:xfrm>
+            <a:off x="3246120" y="1353312"/>
+            <a:ext cx="1051560" cy="292608"/>
+          </a:xfrm>
+          <a:prstGeom prst="roundRect">
+            <a:avLst>
+              <a:gd name="adj" fmla="val 50000"/>
+            </a:avLst>
+          </a:prstGeom>
+          <a:solidFill>
+            <a:schemeClr val="accent6"/>
+          </a:solidFill>
+          <a:ln/>
+        </p:spPr>
+      </p:sp>
+      <p:sp>
+        <p:nvSpPr>
+          <p:cNvPr id="6" name="Demo outcome label 1"/>
+          <p:cNvSpPr txBox="1"/>
+          <p:nvPr/>
+        </p:nvSpPr>
+        <p:spPr>
+          <a:xfrm>
+            <a:off x="3246120" y="1353312"/>
+            <a:ext cx="1051560" cy="292608"/>
+          </a:xfrm>
+          <a:prstGeom prst="rect">
+            <a:avLst/>
+          </a:prstGeom>
+          <a:noFill/>
+          <a:ln/>
+        </p:spPr>
+        <p:txBody>
+          <a:bodyPr wrap="square" lIns="0" tIns="0" rIns="0" bIns="0" rtlCol="0" anchor="ctr"/>
+          <a:lstStyle/>
+          <a:p>
+            <a:pPr algn="ctr" indent="0" marL="0">
+              <a:buNone/>
+            </a:pPr>
+            <a:r>
+              <a:rPr lang="en-US" sz="1100" b="1" dirty="0">
+                <a:solidFill>
+                  <a:schemeClr val="bg1"/>
+                </a:solidFill>
+              </a:rPr>
+              <a:t>PARTIAL</a:t>
+            </a:r>
+            <a:endParaRPr lang="en-US" sz="1100" dirty="0"/>
+          </a:p>
+        </p:txBody>
+      </p:sp>
+      <p:sp>
+        <p:nvSpPr>
+          <p:cNvPr id="7" name="Demo headline 1"/>
+          <p:cNvSpPr txBox="1"/>
+          <p:nvPr/>
+        </p:nvSpPr>
+        <p:spPr>
+          <a:xfrm>
+            <a:off x="640080" y="1737360"/>
+            <a:ext cx="3657600" cy="502920"/>
+          </a:xfrm>
+          <a:prstGeom prst="rect">
+            <a:avLst/>
+          </a:prstGeom>
+          <a:noFill/>
+          <a:ln/>
+        </p:spPr>
+        <p:txBody>
+          <a:bodyPr wrap="square" lIns="0" tIns="0" rIns="0" bIns="0" rtlCol="0" anchor="t"/>
+          <a:lstStyle/>
+          <a:p>
+            <a:pPr indent="0" marL="0">
+              <a:buNone/>
+            </a:pPr>
+            <a:r>
+              <a:rPr lang="en-US" sz="1600" b="1" dirty="0">
+                <a:solidFill>
+                  <a:schemeClr val="tx1"/>
+                </a:solidFill>
+              </a:rPr>
+              <a:t>Room rent above the plan cap</a:t>
+            </a:r>
+            <a:endParaRPr lang="en-US" sz="1600" dirty="0"/>
+          </a:p>
+        </p:txBody>
+      </p:sp>
+      <p:sp>
+        <p:nvSpPr>
+          <p:cNvPr id="8" name="Demo detail 1"/>
+          <p:cNvSpPr txBox="1"/>
+          <p:nvPr/>
+        </p:nvSpPr>
+        <p:spPr>
+          <a:xfrm>
+            <a:off x="640080" y="2240280"/>
+            <a:ext cx="3657600" cy="365760"/>
+          </a:xfrm>
+          <a:prstGeom prst="rect">
+            <a:avLst/>
+          </a:prstGeom>
+          <a:noFill/>
+          <a:ln/>
+        </p:spPr>
+        <p:txBody>
+          <a:bodyPr wrap="square" lIns="0" tIns="0" rIns="0" bIns="0" rtlCol="0" anchor="t"/>
+          <a:lstStyle/>
+          <a:p>
+            <a:pPr indent="0" marL="0">
+              <a:buNone/>
+            </a:pPr>
+            <a:r>
+              <a:rPr lang="en-US" sz="1300" dirty="0">
+                <a:solidFill>
+                  <a:schemeClr val="tx2"/>
+                </a:solidFill>
+              </a:rPr>
+              <a:t>Proportionate deduction, clause C6</a:t>
+            </a:r>
+            <a:endParaRPr lang="en-US" sz="1300" dirty="0"/>
+          </a:p>
+        </p:txBody>
+      </p:sp>
+      <p:sp>
+        <p:nvSpPr>
+          <p:cNvPr id="9" name="Demo card 2"/>
+          <p:cNvSpPr/>
+          <p:nvPr/>
+        </p:nvSpPr>
+        <p:spPr>
+          <a:xfrm>
+            <a:off x="4663440" y="1234440"/>
+            <a:ext cx="4023360" cy="1463040"/>
+          </a:xfrm>
+          <a:prstGeom prst="roundRect">
+            <a:avLst>
+              <a:gd name="adj" fmla="val 5000"/>
+            </a:avLst>
+          </a:prstGeom>
+          <a:solidFill>
+            <a:schemeClr val="bg2"/>
+          </a:solidFill>
+          <a:ln/>
+        </p:spPr>
+      </p:sp>
+      <p:sp>
+        <p:nvSpPr>
+          <p:cNvPr id="10" name="Demo id 2"/>
+          <p:cNvSpPr txBox="1"/>
+          <p:nvPr/>
+        </p:nvSpPr>
+        <p:spPr>
+          <a:xfrm>
+            <a:off x="4846320" y="1371600"/>
+            <a:ext cx="2377440" cy="274320"/>
+          </a:xfrm>
+          <a:prstGeom prst="rect">
+            <a:avLst/>
+          </a:prstGeom>
+          <a:noFill/>
+          <a:ln/>
+        </p:spPr>
+        <p:txBody>
+          <a:bodyPr wrap="square" lIns="0" tIns="0" rIns="0" bIns="0" rtlCol="0" anchor="t"/>
+          <a:lstStyle/>
+          <a:p>
+            <a:pPr indent="0" marL="0">
+              <a:buNone/>
+            </a:pPr>
+            <a:r>
+              <a:rPr lang="en-US" sz="1200" b="1" dirty="0">
+                <a:solidFill>
+                  <a:schemeClr val="tx2"/>
+                </a:solidFill>
+              </a:rPr>
+              <a:t>CLM-26-0007</a:t>
+            </a:r>
+            <a:endParaRPr lang="en-US" sz="1200" dirty="0"/>
+          </a:p>
+        </p:txBody>
+      </p:sp>
+      <p:sp>
+        <p:nvSpPr>
+          <p:cNvPr id="11" name="Demo outcome 2"/>
+          <p:cNvSpPr/>
+          <p:nvPr/>
+        </p:nvSpPr>
+        <p:spPr>
+          <a:xfrm>
+            <a:off x="7452360" y="1353312"/>
+            <a:ext cx="1051560" cy="292608"/>
+          </a:xfrm>
+          <a:prstGeom prst="roundRect">
+            <a:avLst>
+              <a:gd name="adj" fmla="val 50000"/>
+            </a:avLst>
+          </a:prstGeom>
+          <a:solidFill>
+            <a:schemeClr val="accent5"/>
+          </a:solidFill>
+          <a:ln/>
+        </p:spPr>
+      </p:sp>
+      <p:sp>
+        <p:nvSpPr>
+          <p:cNvPr id="12" name="Demo outcome label 2"/>
+          <p:cNvSpPr txBox="1"/>
+          <p:nvPr/>
+        </p:nvSpPr>
+        <p:spPr>
+          <a:xfrm>
+            <a:off x="7452360" y="1353312"/>
+            <a:ext cx="1051560" cy="292608"/>
+          </a:xfrm>
+          <a:prstGeom prst="rect">
+            <a:avLst/>
+          </a:prstGeom>
+          <a:noFill/>
+          <a:ln/>
+        </p:spPr>
+        <p:txBody>
+          <a:bodyPr wrap="square" lIns="0" tIns="0" rIns="0" bIns="0" rtlCol="0" anchor="ctr"/>
+          <a:lstStyle/>
+          <a:p>
+            <a:pPr algn="ctr" indent="0" marL="0">
+              <a:buNone/>
+            </a:pPr>
+            <a:r>
+              <a:rPr lang="en-US" sz="1100" b="1" dirty="0">
+                <a:solidFill>
+                  <a:schemeClr val="bg1"/>
+                </a:solidFill>
+              </a:rPr>
+              <a:t>REJECT</a:t>
+            </a:r>
+            <a:endParaRPr lang="en-US" sz="1100" dirty="0"/>
+          </a:p>
+        </p:txBody>
+      </p:sp>
+      <p:sp>
+        <p:nvSpPr>
+          <p:cNvPr id="13" name="Demo headline 2"/>
+          <p:cNvSpPr txBox="1"/>
+          <p:nvPr/>
+        </p:nvSpPr>
+        <p:spPr>
+          <a:xfrm>
+            <a:off x="4846320" y="1737360"/>
+            <a:ext cx="3657600" cy="502920"/>
+          </a:xfrm>
+          <a:prstGeom prst="rect">
+            <a:avLst/>
+          </a:prstGeom>
+          <a:noFill/>
+          <a:ln/>
+        </p:spPr>
+        <p:txBody>
+          <a:bodyPr wrap="square" lIns="0" tIns="0" rIns="0" bIns="0" rtlCol="0" anchor="t"/>
+          <a:lstStyle/>
+          <a:p>
+            <a:pPr indent="0" marL="0">
+              <a:buNone/>
+            </a:pPr>
+            <a:r>
+              <a:rPr lang="en-US" sz="1600" b="1" dirty="0">
+                <a:solidFill>
+                  <a:schemeClr val="tx1"/>
+                </a:solidFill>
+              </a:rPr>
+              <a:t>Pre-existing condition inside 24 months</a:t>
+            </a:r>
+            <a:endParaRPr lang="en-US" sz="1600" dirty="0"/>
+          </a:p>
+        </p:txBody>
+      </p:sp>
+      <p:sp>
+        <p:nvSpPr>
+          <p:cNvPr id="14" name="Demo detail 2"/>
+          <p:cNvSpPr txBox="1"/>
+          <p:nvPr/>
+        </p:nvSpPr>
+        <p:spPr>
+          <a:xfrm>
+            <a:off x="4846320" y="2240280"/>
+            <a:ext cx="3657600" cy="365760"/>
+          </a:xfrm>
+          <a:prstGeom prst="rect">
+            <a:avLst/>
+          </a:prstGeom>
+          <a:noFill/>
+          <a:ln/>
+        </p:spPr>
+        <p:txBody>
+          <a:bodyPr wrap="square" lIns="0" tIns="0" rIns="0" bIns="0" rtlCol="0" anchor="t"/>
+          <a:lstStyle/>
+          <a:p>
+            <a:pPr indent="0" marL="0">
+              <a:buNone/>
+            </a:pPr>
+            <a:r>
+              <a:rPr lang="en-US" sz="1300" dirty="0">
+                <a:solidFill>
+                  <a:schemeClr val="tx2"/>
+                </a:solidFill>
+              </a:rPr>
+              <a:t>Early exit, remaining checks skipped, clause C3</a:t>
+            </a:r>
+            <a:endParaRPr lang="en-US" sz="1300" dirty="0"/>
+          </a:p>
+        </p:txBody>
+      </p:sp>
+      <p:sp>
+        <p:nvSpPr>
+          <p:cNvPr id="15" name="Demo card 3"/>
+          <p:cNvSpPr/>
+          <p:nvPr/>
+        </p:nvSpPr>
+        <p:spPr>
+          <a:xfrm>
+            <a:off x="457200" y="2880360"/>
+            <a:ext cx="4023360" cy="1463040"/>
+          </a:xfrm>
+          <a:prstGeom prst="roundRect">
+            <a:avLst>
+              <a:gd name="adj" fmla="val 5000"/>
+            </a:avLst>
+          </a:prstGeom>
+          <a:solidFill>
+            <a:schemeClr val="bg2"/>
+          </a:solidFill>
+          <a:ln/>
+        </p:spPr>
+      </p:sp>
+      <p:sp>
+        <p:nvSpPr>
+          <p:cNvPr id="16" name="Demo id 3"/>
+          <p:cNvSpPr txBox="1"/>
+          <p:nvPr/>
+        </p:nvSpPr>
+        <p:spPr>
+          <a:xfrm>
+            <a:off x="640080" y="3017520"/>
+            <a:ext cx="2377440" cy="274320"/>
+          </a:xfrm>
+          <a:prstGeom prst="rect">
+            <a:avLst/>
+          </a:prstGeom>
+          <a:noFill/>
+          <a:ln/>
+        </p:spPr>
+        <p:txBody>
+          <a:bodyPr wrap="square" lIns="0" tIns="0" rIns="0" bIns="0" rtlCol="0" anchor="t"/>
+          <a:lstStyle/>
+          <a:p>
+            <a:pPr indent="0" marL="0">
+              <a:buNone/>
+            </a:pPr>
+            <a:r>
+              <a:rPr lang="en-US" sz="1200" b="1" dirty="0">
+                <a:solidFill>
+                  <a:schemeClr val="tx2"/>
+                </a:solidFill>
+              </a:rPr>
+              <a:t>CLM-26-0019</a:t>
+            </a:r>
+            <a:endParaRPr lang="en-US" sz="1200" dirty="0"/>
+          </a:p>
+        </p:txBody>
+      </p:sp>
+      <p:sp>
+        <p:nvSpPr>
+          <p:cNvPr id="17" name="Demo outcome 3"/>
+          <p:cNvSpPr/>
+          <p:nvPr/>
+        </p:nvSpPr>
+        <p:spPr>
+          <a:xfrm>
+            <a:off x="3246120" y="2999232"/>
+            <a:ext cx="1051560" cy="292608"/>
+          </a:xfrm>
+          <a:prstGeom prst="roundRect">
+            <a:avLst>
+              <a:gd name="adj" fmla="val 50000"/>
+            </a:avLst>
+          </a:prstGeom>
+          <a:solidFill>
+            <a:schemeClr val="accent2"/>
+          </a:solidFill>
+          <a:ln/>
+        </p:spPr>
+      </p:sp>
+      <p:sp>
+        <p:nvSpPr>
+          <p:cNvPr id="18" name="Demo outcome label 3"/>
+          <p:cNvSpPr txBox="1"/>
+          <p:nvPr/>
+        </p:nvSpPr>
+        <p:spPr>
+          <a:xfrm>
+            <a:off x="3246120" y="2999232"/>
+            <a:ext cx="1051560" cy="292608"/>
+          </a:xfrm>
+          <a:prstGeom prst="rect">
+            <a:avLst/>
+          </a:prstGeom>
+          <a:noFill/>
+          <a:ln/>
+        </p:spPr>
+        <p:txBody>
+          <a:bodyPr wrap="square" lIns="0" tIns="0" rIns="0" bIns="0" rtlCol="0" anchor="ctr"/>
+          <a:lstStyle/>
+          <a:p>
+            <a:pPr algn="ctr" indent="0" marL="0">
+              <a:buNone/>
+            </a:pPr>
+            <a:r>
+              <a:rPr lang="en-US" sz="1100" b="1" dirty="0">
+                <a:solidFill>
+                  <a:schemeClr val="bg1"/>
+                </a:solidFill>
+              </a:rPr>
+              <a:t>ESCALATE</a:t>
+            </a:r>
+            <a:endParaRPr lang="en-US" sz="1100" dirty="0"/>
+          </a:p>
+        </p:txBody>
+      </p:sp>
+      <p:sp>
+        <p:nvSpPr>
+          <p:cNvPr id="19" name="Demo headline 3"/>
+          <p:cNvSpPr txBox="1"/>
+          <p:nvPr/>
+        </p:nvSpPr>
+        <p:spPr>
+          <a:xfrm>
+            <a:off x="640080" y="3383280"/>
+            <a:ext cx="3657600" cy="502920"/>
+          </a:xfrm>
+          <a:prstGeom prst="rect">
+            <a:avLst/>
+          </a:prstGeom>
+          <a:noFill/>
+          <a:ln/>
+        </p:spPr>
+        <p:txBody>
+          <a:bodyPr wrap="square" lIns="0" tIns="0" rIns="0" bIns="0" rtlCol="0" anchor="t"/>
+          <a:lstStyle/>
+          <a:p>
+            <a:pPr indent="0" marL="0">
+              <a:buNone/>
+            </a:pPr>
+            <a:r>
+              <a:rPr lang="en-US" sz="1600" b="1" dirty="0">
+                <a:solidFill>
+                  <a:schemeClr val="tx1"/>
+                </a:solidFill>
+              </a:rPr>
+              <a:t>Quick plan misses an inflated bill</a:t>
+            </a:r>
+            <a:endParaRPr lang="en-US" sz="1600" dirty="0"/>
+          </a:p>
+        </p:txBody>
+      </p:sp>
+      <p:sp>
+        <p:nvSpPr>
+          <p:cNvPr id="20" name="Demo detail 3"/>
+          <p:cNvSpPr txBox="1"/>
+          <p:nvPr/>
+        </p:nvSpPr>
+        <p:spPr>
+          <a:xfrm>
+            <a:off x="640080" y="3886200"/>
+            <a:ext cx="3657600" cy="365760"/>
+          </a:xfrm>
+          <a:prstGeom prst="rect">
+            <a:avLst/>
+          </a:prstGeom>
+          <a:noFill/>
+          <a:ln/>
+        </p:spPr>
+        <p:txBody>
+          <a:bodyPr wrap="square" lIns="0" tIns="0" rIns="0" bIns="0" rtlCol="0" anchor="t"/>
+          <a:lstStyle/>
+          <a:p>
+            <a:pPr indent="0" marL="0">
+              <a:buNone/>
+            </a:pPr>
+            <a:r>
+              <a:rPr lang="en-US" sz="1300" dirty="0">
+                <a:solidFill>
+                  <a:schemeClr val="tx2"/>
+                </a:solidFill>
+              </a:rPr>
+              <a:t>Critic sends it back, fraud score, human review</a:t>
+            </a:r>
+            <a:endParaRPr lang="en-US" sz="1300" dirty="0"/>
+          </a:p>
+        </p:txBody>
+      </p:sp>
+      <p:sp>
+        <p:nvSpPr>
+          <p:cNvPr id="21" name="Demo card 4"/>
+          <p:cNvSpPr/>
+          <p:nvPr/>
+        </p:nvSpPr>
+        <p:spPr>
+          <a:xfrm>
+            <a:off x="4663440" y="2880360"/>
+            <a:ext cx="4023360" cy="1463040"/>
+          </a:xfrm>
+          <a:prstGeom prst="roundRect">
+            <a:avLst>
+              <a:gd name="adj" fmla="val 5000"/>
+            </a:avLst>
+          </a:prstGeom>
+          <a:solidFill>
+            <a:schemeClr val="bg2"/>
+          </a:solidFill>
+          <a:ln/>
+        </p:spPr>
+      </p:sp>
+      <p:sp>
+        <p:nvSpPr>
+          <p:cNvPr id="22" name="Demo id 4"/>
+          <p:cNvSpPr txBox="1"/>
+          <p:nvPr/>
+        </p:nvSpPr>
+        <p:spPr>
+          <a:xfrm>
+            <a:off x="4846320" y="3017520"/>
+            <a:ext cx="2377440" cy="274320"/>
+          </a:xfrm>
+          <a:prstGeom prst="rect">
+            <a:avLst/>
+          </a:prstGeom>
+          <a:noFill/>
+          <a:ln/>
+        </p:spPr>
+        <p:txBody>
+          <a:bodyPr wrap="square" lIns="0" tIns="0" rIns="0" bIns="0" rtlCol="0" anchor="t"/>
+          <a:lstStyle/>
+          <a:p>
+            <a:pPr indent="0" marL="0">
+              <a:buNone/>
+            </a:pPr>
+            <a:r>
+              <a:rPr lang="en-US" sz="1200" b="1" dirty="0">
+                <a:solidFill>
+                  <a:schemeClr val="tx2"/>
+                </a:solidFill>
+              </a:rPr>
+              <a:t>CLM-26-0003 + error</a:t>
+            </a:r>
+            <a:endParaRPr lang="en-US" sz="1200" dirty="0"/>
+          </a:p>
+        </p:txBody>
+      </p:sp>
+      <p:sp>
+        <p:nvSpPr>
+          <p:cNvPr id="23" name="Demo outcome 4"/>
+          <p:cNvSpPr/>
+          <p:nvPr/>
+        </p:nvSpPr>
+        <p:spPr>
+          <a:xfrm>
+            <a:off x="7452360" y="2999232"/>
+            <a:ext cx="1051560" cy="292608"/>
+          </a:xfrm>
+          <a:prstGeom prst="roundRect">
+            <a:avLst>
+              <a:gd name="adj" fmla="val 50000"/>
+            </a:avLst>
+          </a:prstGeom>
+          <a:solidFill>
+            <a:schemeClr val="accent4"/>
+          </a:solidFill>
+          <a:ln/>
+        </p:spPr>
+      </p:sp>
+      <p:sp>
+        <p:nvSpPr>
+          <p:cNvPr id="24" name="Demo outcome label 4"/>
+          <p:cNvSpPr txBox="1"/>
+          <p:nvPr/>
+        </p:nvSpPr>
+        <p:spPr>
+          <a:xfrm>
+            <a:off x="7452360" y="2999232"/>
+            <a:ext cx="1051560" cy="292608"/>
+          </a:xfrm>
+          <a:prstGeom prst="rect">
+            <a:avLst/>
+          </a:prstGeom>
+          <a:noFill/>
+          <a:ln/>
+        </p:spPr>
+        <p:txBody>
+          <a:bodyPr wrap="square" lIns="0" tIns="0" rIns="0" bIns="0" rtlCol="0" anchor="ctr"/>
+          <a:lstStyle/>
+          <a:p>
+            <a:pPr algn="ctr" indent="0" marL="0">
+              <a:buNone/>
+            </a:pPr>
+            <a:r>
+              <a:rPr lang="en-US" sz="1100" b="1" dirty="0">
+                <a:solidFill>
+                  <a:schemeClr val="bg1"/>
+                </a:solidFill>
+              </a:rPr>
+              <a:t>APPROVE</a:t>
+            </a:r>
+            <a:endParaRPr lang="en-US" sz="1100" dirty="0"/>
+          </a:p>
+        </p:txBody>
+      </p:sp>
+      <p:sp>
+        <p:nvSpPr>
+          <p:cNvPr id="25" name="Demo headline 4"/>
+          <p:cNvSpPr txBox="1"/>
+          <p:nvPr/>
+        </p:nvSpPr>
+        <p:spPr>
+          <a:xfrm>
+            <a:off x="4846320" y="3383280"/>
+            <a:ext cx="3657600" cy="502920"/>
+          </a:xfrm>
+          <a:prstGeom prst="rect">
+            <a:avLst/>
+          </a:prstGeom>
+          <a:noFill/>
+          <a:ln/>
+        </p:spPr>
+        <p:txBody>
+          <a:bodyPr wrap="square" lIns="0" tIns="0" rIns="0" bIns="0" rtlCol="0" anchor="t"/>
+          <a:lstStyle/>
+          <a:p>
+            <a:pPr indent="0" marL="0">
+              <a:buNone/>
+            </a:pPr>
+            <a:r>
+              <a:rPr lang="en-US" sz="1600" b="1" dirty="0">
+                <a:solidFill>
+                  <a:schemeClr val="tx1"/>
+                </a:solidFill>
+              </a:rPr>
+              <a:t>Executor overpays by 15% on purpose</a:t>
+            </a:r>
+            <a:endParaRPr lang="en-US" sz="1600" dirty="0"/>
+          </a:p>
+        </p:txBody>
+      </p:sp>
+      <p:sp>
+        <p:nvSpPr>
+          <p:cNvPr id="26" name="Demo detail 4"/>
+          <p:cNvSpPr txBox="1"/>
+          <p:nvPr/>
+        </p:nvSpPr>
+        <p:spPr>
+          <a:xfrm>
+            <a:off x="4846320" y="3886200"/>
+            <a:ext cx="3657600" cy="365760"/>
+          </a:xfrm>
+          <a:prstGeom prst="rect">
+            <a:avLst/>
+          </a:prstGeom>
+          <a:noFill/>
+          <a:ln/>
+        </p:spPr>
+        <p:txBody>
+          <a:bodyPr wrap="square" lIns="0" tIns="0" rIns="0" bIns="0" rtlCol="0" anchor="t"/>
+          <a:lstStyle/>
+          <a:p>
+            <a:pPr indent="0" marL="0">
+              <a:buNone/>
+            </a:pPr>
+            <a:r>
+              <a:rPr lang="en-US" sz="1300" dirty="0">
+                <a:solidFill>
+                  <a:schemeClr val="tx2"/>
+                </a:solidFill>
+              </a:rPr>
+              <a:t>Critic catches it, recomputes, passes</a:t>
+            </a:r>
+            <a:endParaRPr lang="en-US" sz="1300" dirty="0"/>
+          </a:p>
+        </p:txBody>
+      </p:sp>
+      <p:sp>
+        <p:nvSpPr>
+          <p:cNvPr id="25" name="Slide Number Placeholder 0"/>
+          <p:cNvSpPr>
+            <a:spLocks noGrp="1"/>
+          </p:cNvSpPr>
+          <p:nvPr>
+            <p:ph type="sldNum" sz="quarter" idx="4294967295"/>
+          </p:nvPr>
+        </p:nvSpPr>
+        <p:spPr>
+          <a:xfrm>
+            <a:off x="8321040" y="4773168"/>
+            <a:ext cx="457200" cy="228600"/>
+          </a:xfrm>
+          <a:prstGeom prst="rect">
+            <a:avLst/>
+          </a:prstGeom>
+          <a:extLst>
+            <a:ext uri="{C572A759-6A51-4108-AA02-DFA0A04FC94B}">
+              <ma14:wrappingTextBoxFlag xmlns:ma14="http://schemas.microsoft.com/office/mac/drawingml/2011/main" val="0"/>
+            </a:ext>
+          </a:extLst>
+        </p:spPr>
+        <p:txBody>
+          <a:bodyPr/>
+          <a:lstStyle>
+            <a:lvl1pPr>
+              <a:defRPr sz="1000">
+                <a:solidFill>
+                  <a:schemeClr val="tx2"/>
+                </a:solidFill>
+              </a:defRPr>
+            </a:lvl1pPr>
+          </a:lstStyle>
+          <a:p>
+            <a:pPr algn="r"/>
+            <a:fld id="{F7021451-1387-4CA6-816F-3879F97B5CBC}" type="slidenum">
+              <a:rPr b="0" lang="en-US"/>
+              <a:t>11</a:t>
+            </a:fld>
+            <a:endParaRPr lang="en-US"/>
+          </a:p>
+        </p:txBody>
+      </p:sp>
+    </p:spTree>
+  </p:cSld>
+  <p:clrMapOvr>
+    <a:masterClrMapping/>
+  </p:clrMapOvr>
+</p:sld>
+</file>
+
+<file path=ppt/slides/slide12.xml><?xml version="1.0" encoding="utf-8"?>
+<p:sld xmlns:a="http://schemas.openxmlformats.org/drawingml/2006/main" xmlns:r="http://schemas.openxmlformats.org/officeDocument/2006/relationships" xmlns:p="http://schemas.openxmlformats.org/presentationml/2006/main">
+  <p:cSld name="Slide 12">
+    <p:spTree>
+      <p:nvGrpSpPr>
+        <p:cNvPr id="1" name=""/>
+        <p:cNvGrpSpPr/>
+        <p:nvPr/>
+      </p:nvGrpSpPr>
+      <p:grpSpPr>
+        <a:xfrm>
+          <a:off x="0" y="0"/>
+          <a:ext cx="0" cy="0"/>
+          <a:chOff x="0" y="0"/>
+          <a:chExt cx="0" cy="0"/>
+        </a:xfrm>
+      </p:grpSpPr>
+      <p:sp>
+        <p:nvSpPr>
+          <p:cNvPr id="2" name="Text 0"/>
+          <p:cNvSpPr/>
+          <p:nvPr>
+            <p:ph idx="100" type="title" hasCustomPrompt="1"/>
+          </p:nvPr>
+        </p:nvSpPr>
+        <p:spPr>
+          <a:xfrm>
+            <a:off x="457200" y="292608"/>
+            <a:ext cx="8229600" cy="777240"/>
+          </a:xfrm>
+          <a:prstGeom prst="rect">
+            <a:avLst/>
+          </a:prstGeom>
+          <a:noFill/>
+          <a:ln/>
+        </p:spPr>
+        <p:txBody>
+          <a:bodyPr wrap="square" lIns="0" tIns="0" rIns="0" bIns="0" rtlCol="0" anchor="t"/>
+          <a:lstStyle/>
+          <a:p>
+            <a:pPr algn="l" indent="0" marL="0">
+              <a:buNone/>
+            </a:pPr>
+            <a:r>
+              <a:rPr lang="en-US" sz="2800" b="1" dirty="0">
+                <a:solidFill>
+                  <a:schemeClr val="tx1"/>
+                </a:solidFill>
+              </a:rPr>
               <a:t>Appendix: full architecture diagram</a:t>
             </a:r>
             <a:endParaRPr lang="en-US" sz="2800" dirty="0"/>
@@ -4438,7 +5296,7 @@
             <a:pPr algn="r"/>
             <a:fld id="{F7021451-1387-4CA6-816F-3879F97B5CBC}" type="slidenum">
               <a:rPr b="0" lang="en-US"/>
-              <a:t>11</a:t>
+              <a:t>12</a:t>
             </a:fld>
             <a:endParaRPr lang="en-US"/>
           </a:p>
@@ -5795,7 +6653,7 @@
                   <a:schemeClr val="tx1"/>
                 </a:solidFill>
               </a:rPr>
-              <a:t>Reads the discharge summary</a:t>
+              <a:t>Reads the summary, with a local language model</a:t>
             </a:r>
             <a:endParaRPr lang="en-US" sz="1300" dirty="0"/>
           </a:p>
@@ -6623,7 +7481,7 @@
                   <a:schemeClr val="tx2"/>
                 </a:solidFill>
               </a:rPr>
-              <a:t>Plus a pluggable model (mock or local Ollama) and synthetic policy, member and hospital stores.</a:t>
+              <a:t>Plus a local language model (Ollama, llama3.2:3b) and synthetic policy, member and hospital stores.</a:t>
             </a:r>
             <a:endParaRPr lang="en-US" sz="1200" dirty="0"/>
           </a:p>
@@ -8162,7 +9020,7 @@
                   <a:schemeClr val="tx1"/>
                 </a:solidFill>
               </a:rPr>
-              <a:t>Tested on held-out claims with added noise</a:t>
+              <a:t>First, hardening the rules with noisy claims</a:t>
             </a:r>
             <a:endParaRPr lang="en-US" sz="2800" dirty="0"/>
           </a:p>
@@ -8613,26 +9471,42 @@
                   <a:schemeClr val="tx1"/>
                 </a:solidFill>
               </a:rPr>
-              <a:t>Limitations and what comes next</a:t>
+              <a:t>Then a real language model closes the gap</a:t>
             </a:r>
             <a:endParaRPr lang="en-US" sz="2800" dirty="0"/>
           </a:p>
         </p:txBody>
       </p:sp>
-      <p:sp>
-        <p:nvSpPr>
-          <p:cNvPr id="3" name="Limits card"/>
+      <p:graphicFrame>
+        <p:nvGraphicFramePr>
+          <p:cNvPr id="3" name="Chart 0" descr=""/>
+          <p:cNvGraphicFramePr/>
+          <p:nvPr/>
+        </p:nvGraphicFramePr>
+        <p:xfrm>
+          <a:off x="365760" y="1097280"/>
+          <a:ext cx="5394960" cy="3154680"/>
+        </p:xfrm>
+        <a:graphic xmlns:a="http://schemas.openxmlformats.org/drawingml/2006/main">
+          <a:graphicData uri="http://schemas.openxmlformats.org/drawingml/2006/chart">
+            <c:chart xmlns:c="http://schemas.openxmlformats.org/drawingml/2006/chart" r:id="rId1"/>
+          </a:graphicData>
+        </a:graphic>
+      </p:graphicFrame>
+      <p:sp>
+        <p:nvSpPr>
+          <p:cNvPr id="4" name="LLM card 1"/>
           <p:cNvSpPr/>
           <p:nvPr/>
         </p:nvSpPr>
         <p:spPr>
           <a:xfrm>
-            <a:off x="457200" y="1234440"/>
-            <a:ext cx="3977640" cy="3246120"/>
+            <a:off x="5989320" y="1188720"/>
+            <a:ext cx="2697480" cy="950976"/>
           </a:xfrm>
           <a:prstGeom prst="roundRect">
             <a:avLst>
-              <a:gd name="adj" fmla="val 2254"/>
+              <a:gd name="adj" fmla="val 7692"/>
             </a:avLst>
           </a:prstGeom>
           <a:solidFill>
@@ -8643,14 +9517,14 @@
       </p:sp>
       <p:sp>
         <p:nvSpPr>
-          <p:cNvPr id="4" name="Limits heading"/>
-          <p:cNvSpPr txBox="1"/>
-          <p:nvPr/>
-        </p:nvSpPr>
-        <p:spPr>
-          <a:xfrm>
-            <a:off x="685800" y="1371600"/>
-            <a:ext cx="3566160" cy="365760"/>
+          <p:cNvPr id="5" name="LLM card head 1"/>
+          <p:cNvSpPr txBox="1"/>
+          <p:nvPr/>
+        </p:nvSpPr>
+        <p:spPr>
+          <a:xfrm>
+            <a:off x="6126480" y="1252728"/>
+            <a:ext cx="2468880" cy="228600"/>
           </a:xfrm>
           <a:prstGeom prst="rect">
             <a:avLst/>
@@ -8666,128 +9540,106 @@
               <a:buNone/>
             </a:pPr>
             <a:r>
-              <a:rPr lang="en-US" sz="2000" b="1" dirty="0">
-                <a:solidFill>
-                  <a:schemeClr val="accent2"/>
+              <a:rPr lang="en-US" sz="1100" b="1" spc="100" kern="0" dirty="0">
+                <a:solidFill>
+                  <a:schemeClr val="tx2"/>
+                </a:solidFill>
+              </a:rPr>
+              <a:t>Abbreviations</a:t>
+            </a:r>
+            <a:endParaRPr lang="en-US" sz="1100" dirty="0"/>
+          </a:p>
+        </p:txBody>
+      </p:sp>
+      <p:sp>
+        <p:nvSpPr>
+          <p:cNvPr id="6" name="LLM card value 1"/>
+          <p:cNvSpPr txBox="1"/>
+          <p:nvPr/>
+        </p:nvSpPr>
+        <p:spPr>
+          <a:xfrm>
+            <a:off x="6126480" y="1463040"/>
+            <a:ext cx="1325880" cy="585216"/>
+          </a:xfrm>
+          <a:prstGeom prst="rect">
+            <a:avLst/>
+          </a:prstGeom>
+          <a:noFill/>
+          <a:ln/>
+        </p:spPr>
+        <p:txBody>
+          <a:bodyPr wrap="square" lIns="0" tIns="0" rIns="0" bIns="0" rtlCol="0" anchor="ctr"/>
+          <a:lstStyle/>
+          <a:p>
+            <a:pPr indent="0" marL="0">
+              <a:buNone/>
+            </a:pPr>
+            <a:r>
+              <a:rPr lang="en-US" sz="2400" b="1" dirty="0">
+                <a:solidFill>
+                  <a:schemeClr val="accent1"/>
                 </a:solidFill>
                 <a:latin typeface="Cambria" pitchFamily="34" charset="0"/>
                 <a:ea typeface="Cambria" pitchFamily="34" charset="-122"/>
                 <a:cs typeface="Cambria" pitchFamily="34" charset="-120"/>
               </a:rPr>
-              <a:t>Limitations</a:t>
-            </a:r>
-            <a:endParaRPr lang="en-US" sz="2000" dirty="0"/>
-          </a:p>
-        </p:txBody>
-      </p:sp>
-      <p:sp>
-        <p:nvSpPr>
-          <p:cNvPr id="5" name="Limits list"/>
-          <p:cNvSpPr txBox="1"/>
-          <p:nvPr/>
-        </p:nvSpPr>
-        <p:spPr>
-          <a:xfrm>
-            <a:off x="685800" y="1828800"/>
-            <a:ext cx="3566160" cy="2560320"/>
-          </a:xfrm>
-          <a:prstGeom prst="rect">
-            <a:avLst/>
-          </a:prstGeom>
-          <a:noFill/>
-          <a:ln/>
-        </p:spPr>
-        <p:txBody>
-          <a:bodyPr wrap="square" lIns="0" tIns="0" rIns="0" bIns="0" rtlCol="0" anchor="t"/>
-          <a:lstStyle/>
-          <a:p>
-            <a:pPr marL="342900" indent="-342900">
-              <a:spcAft>
-                <a:spcPts val="700"/>
-              </a:spcAft>
-              <a:buSzPct val="100000"/>
-              <a:buChar char="•"/>
-            </a:pPr>
-            <a:r>
-              <a:rPr lang="en-US" sz="1400" dirty="0">
+              <a:t>5 to 0</a:t>
+            </a:r>
+            <a:endParaRPr lang="en-US" sz="2400" dirty="0"/>
+          </a:p>
+        </p:txBody>
+      </p:sp>
+      <p:sp>
+        <p:nvSpPr>
+          <p:cNvPr id="7" name="LLM card text 1"/>
+          <p:cNvSpPr txBox="1"/>
+          <p:nvPr/>
+        </p:nvSpPr>
+        <p:spPr>
+          <a:xfrm>
+            <a:off x="7406640" y="1481328"/>
+            <a:ext cx="1188720" cy="566928"/>
+          </a:xfrm>
+          <a:prstGeom prst="rect">
+            <a:avLst/>
+          </a:prstGeom>
+          <a:noFill/>
+          <a:ln/>
+        </p:spPr>
+        <p:txBody>
+          <a:bodyPr wrap="square" lIns="0" tIns="0" rIns="0" bIns="0" rtlCol="0" anchor="ctr"/>
+          <a:lstStyle/>
+          <a:p>
+            <a:pPr indent="0" marL="0">
+              <a:buNone/>
+            </a:pPr>
+            <a:r>
+              <a:rPr lang="en-US" sz="1100" dirty="0">
                 <a:solidFill>
                   <a:schemeClr val="tx1"/>
                 </a:solidFill>
               </a:rPr>
-              <a:t>All data is synthetic and the summaries are templated</a:t>
-            </a:r>
-            <a:endParaRPr lang="en-US" sz="1400" dirty="0"/>
-          </a:p>
-          <a:p>
-            <a:pPr marL="342900" indent="-342900">
-              <a:spcAft>
-                <a:spcPts val="700"/>
-              </a:spcAft>
-              <a:buSzPct val="100000"/>
-              <a:buChar char="•"/>
-            </a:pPr>
-            <a:r>
-              <a:rPr lang="en-US" sz="1400" dirty="0">
-                <a:solidFill>
-                  <a:schemeClr val="tx1"/>
-                </a:solidFill>
-              </a:rPr>
-              <a:t>Clinical abbreviations can hide a pre-existing condition</a:t>
-            </a:r>
-            <a:endParaRPr lang="en-US" sz="1400" dirty="0"/>
-          </a:p>
-          <a:p>
-            <a:pPr marL="342900" indent="-342900">
-              <a:spcAft>
-                <a:spcPts val="700"/>
-              </a:spcAft>
-              <a:buSzPct val="100000"/>
-              <a:buChar char="•"/>
-            </a:pPr>
-            <a:r>
-              <a:rPr lang="en-US" sz="1400" dirty="0">
-                <a:solidFill>
-                  <a:schemeClr val="tx1"/>
-                </a:solidFill>
-              </a:rPr>
-              <a:t>Fraud weights and tariffs are hand-set, not learned</a:t>
-            </a:r>
-            <a:endParaRPr lang="en-US" sz="1400" dirty="0"/>
-          </a:p>
-          <a:p>
-            <a:pPr marL="342900" indent="-342900">
-              <a:spcAft>
-                <a:spcPts val="700"/>
-              </a:spcAft>
-              <a:buSzPct val="100000"/>
-              <a:buChar char="•"/>
-            </a:pPr>
-            <a:r>
-              <a:rPr lang="en-US" sz="1400" dirty="0">
-                <a:solidFill>
-                  <a:schemeClr val="tx1"/>
-                </a:solidFill>
-              </a:rPr>
-              <a:t>The 25-minute manual baseline is an assumption</a:t>
-            </a:r>
-            <a:endParaRPr lang="en-US" sz="1400" dirty="0"/>
-          </a:p>
-        </p:txBody>
-      </p:sp>
-      <p:sp>
-        <p:nvSpPr>
-          <p:cNvPr id="6" name="Future card"/>
+              <a:t>risky claims wrongly paid, of 48</a:t>
+            </a:r>
+            <a:endParaRPr lang="en-US" sz="1100" dirty="0"/>
+          </a:p>
+        </p:txBody>
+      </p:sp>
+      <p:sp>
+        <p:nvSpPr>
+          <p:cNvPr id="8" name="LLM card 2"/>
           <p:cNvSpPr/>
           <p:nvPr/>
         </p:nvSpPr>
         <p:spPr>
           <a:xfrm>
-            <a:off x="4709160" y="1234440"/>
-            <a:ext cx="3977640" cy="3246120"/>
+            <a:off x="5989320" y="2267712"/>
+            <a:ext cx="2697480" cy="950976"/>
           </a:xfrm>
           <a:prstGeom prst="roundRect">
             <a:avLst>
-              <a:gd name="adj" fmla="val 2254"/>
+              <a:gd name="adj" fmla="val 7692"/>
             </a:avLst>
           </a:prstGeom>
           <a:solidFill>
@@ -8798,14 +9650,14 @@
       </p:sp>
       <p:sp>
         <p:nvSpPr>
-          <p:cNvPr id="7" name="Future heading"/>
-          <p:cNvSpPr txBox="1"/>
-          <p:nvPr/>
-        </p:nvSpPr>
-        <p:spPr>
-          <a:xfrm>
-            <a:off x="4937760" y="1371600"/>
-            <a:ext cx="3566160" cy="365760"/>
+          <p:cNvPr id="9" name="LLM card head 2"/>
+          <p:cNvSpPr txBox="1"/>
+          <p:nvPr/>
+        </p:nvSpPr>
+        <p:spPr>
+          <a:xfrm>
+            <a:off x="6126480" y="2331720"/>
+            <a:ext cx="2468880" cy="228600"/>
           </a:xfrm>
           <a:prstGeom prst="rect">
             <a:avLst/>
@@ -8821,7 +9673,43 @@
               <a:buNone/>
             </a:pPr>
             <a:r>
-              <a:rPr lang="en-US" sz="2000" b="1" dirty="0">
+              <a:rPr lang="en-US" sz="1100" b="1" spc="100" kern="0" dirty="0">
+                <a:solidFill>
+                  <a:schemeClr val="tx2"/>
+                </a:solidFill>
+              </a:rPr>
+              <a:t>Telegraphic notes</a:t>
+            </a:r>
+            <a:endParaRPr lang="en-US" sz="1100" dirty="0"/>
+          </a:p>
+        </p:txBody>
+      </p:sp>
+      <p:sp>
+        <p:nvSpPr>
+          <p:cNvPr id="10" name="LLM card value 2"/>
+          <p:cNvSpPr txBox="1"/>
+          <p:nvPr/>
+        </p:nvSpPr>
+        <p:spPr>
+          <a:xfrm>
+            <a:off x="6126480" y="2542032"/>
+            <a:ext cx="1325880" cy="585216"/>
+          </a:xfrm>
+          <a:prstGeom prst="rect">
+            <a:avLst/>
+          </a:prstGeom>
+          <a:noFill/>
+          <a:ln/>
+        </p:spPr>
+        <p:txBody>
+          <a:bodyPr wrap="square" lIns="0" tIns="0" rIns="0" bIns="0" rtlCol="0" anchor="ctr"/>
+          <a:lstStyle/>
+          <a:p>
+            <a:pPr indent="0" marL="0">
+              <a:buNone/>
+            </a:pPr>
+            <a:r>
+              <a:rPr lang="en-US" sz="2400" b="1" dirty="0">
                 <a:solidFill>
                   <a:schemeClr val="accent1"/>
                 </a:solidFill>
@@ -8829,22 +9717,80 @@
                 <a:ea typeface="Cambria" pitchFamily="34" charset="-122"/>
                 <a:cs typeface="Cambria" pitchFamily="34" charset="-120"/>
               </a:rPr>
-              <a:t>Future scope</a:t>
-            </a:r>
-            <a:endParaRPr lang="en-US" sz="2000" dirty="0"/>
-          </a:p>
-        </p:txBody>
-      </p:sp>
-      <p:sp>
-        <p:nvSpPr>
-          <p:cNvPr id="8" name="Future list"/>
-          <p:cNvSpPr txBox="1"/>
-          <p:nvPr/>
-        </p:nvSpPr>
-        <p:spPr>
-          <a:xfrm>
-            <a:off x="4937760" y="1828800"/>
-            <a:ext cx="3566160" cy="2560320"/>
+              <a:t>8 to 0</a:t>
+            </a:r>
+            <a:endParaRPr lang="en-US" sz="2400" dirty="0"/>
+          </a:p>
+        </p:txBody>
+      </p:sp>
+      <p:sp>
+        <p:nvSpPr>
+          <p:cNvPr id="11" name="LLM card text 2"/>
+          <p:cNvSpPr txBox="1"/>
+          <p:nvPr/>
+        </p:nvSpPr>
+        <p:spPr>
+          <a:xfrm>
+            <a:off x="7406640" y="2560320"/>
+            <a:ext cx="1188720" cy="566928"/>
+          </a:xfrm>
+          <a:prstGeom prst="rect">
+            <a:avLst/>
+          </a:prstGeom>
+          <a:noFill/>
+          <a:ln/>
+        </p:spPr>
+        <p:txBody>
+          <a:bodyPr wrap="square" lIns="0" tIns="0" rIns="0" bIns="0" rtlCol="0" anchor="ctr"/>
+          <a:lstStyle/>
+          <a:p>
+            <a:pPr indent="0" marL="0">
+              <a:buNone/>
+            </a:pPr>
+            <a:r>
+              <a:rPr lang="en-US" sz="1100" dirty="0">
+                <a:solidFill>
+                  <a:schemeClr val="tx1"/>
+                </a:solidFill>
+              </a:rPr>
+              <a:t>risky claims wrongly paid, of 48</a:t>
+            </a:r>
+            <a:endParaRPr lang="en-US" sz="1100" dirty="0"/>
+          </a:p>
+        </p:txBody>
+      </p:sp>
+      <p:sp>
+        <p:nvSpPr>
+          <p:cNvPr id="12" name="LLM card 3"/>
+          <p:cNvSpPr/>
+          <p:nvPr/>
+        </p:nvSpPr>
+        <p:spPr>
+          <a:xfrm>
+            <a:off x="5989320" y="3346704"/>
+            <a:ext cx="2697480" cy="950976"/>
+          </a:xfrm>
+          <a:prstGeom prst="roundRect">
+            <a:avLst>
+              <a:gd name="adj" fmla="val 7692"/>
+            </a:avLst>
+          </a:prstGeom>
+          <a:solidFill>
+            <a:schemeClr val="bg2"/>
+          </a:solidFill>
+          <a:ln/>
+        </p:spPr>
+      </p:sp>
+      <p:sp>
+        <p:nvSpPr>
+          <p:cNvPr id="13" name="LLM card head 3"/>
+          <p:cNvSpPr txBox="1"/>
+          <p:nvPr/>
+        </p:nvSpPr>
+        <p:spPr>
+          <a:xfrm>
+            <a:off x="6126480" y="3410712"/>
+            <a:ext cx="2468880" cy="228600"/>
           </a:xfrm>
           <a:prstGeom prst="rect">
             <a:avLst/>
@@ -8856,76 +9802,129 @@
           <a:bodyPr wrap="square" lIns="0" tIns="0" rIns="0" bIns="0" rtlCol="0" anchor="t"/>
           <a:lstStyle/>
           <a:p>
-            <a:pPr marL="342900" indent="-342900">
-              <a:spcAft>
-                <a:spcPts val="700"/>
-              </a:spcAft>
-              <a:buSzPct val="100000"/>
-              <a:buChar char="•"/>
-            </a:pPr>
-            <a:r>
-              <a:rPr lang="en-US" sz="1400" dirty="0">
+            <a:pPr indent="0" marL="0">
+              <a:buNone/>
+            </a:pPr>
+            <a:r>
+              <a:rPr lang="en-US" sz="1100" b="1" spc="100" kern="0" dirty="0">
+                <a:solidFill>
+                  <a:schemeClr val="tx2"/>
+                </a:solidFill>
+              </a:rPr>
+              <a:t>Needless holds</a:t>
+            </a:r>
+            <a:endParaRPr lang="en-US" sz="1100" dirty="0"/>
+          </a:p>
+        </p:txBody>
+      </p:sp>
+      <p:sp>
+        <p:nvSpPr>
+          <p:cNvPr id="14" name="LLM card value 3"/>
+          <p:cNvSpPr txBox="1"/>
+          <p:nvPr/>
+        </p:nvSpPr>
+        <p:spPr>
+          <a:xfrm>
+            <a:off x="6126480" y="3621024"/>
+            <a:ext cx="1325880" cy="585216"/>
+          </a:xfrm>
+          <a:prstGeom prst="rect">
+            <a:avLst/>
+          </a:prstGeom>
+          <a:noFill/>
+          <a:ln/>
+        </p:spPr>
+        <p:txBody>
+          <a:bodyPr wrap="square" lIns="0" tIns="0" rIns="0" bIns="0" rtlCol="0" anchor="ctr"/>
+          <a:lstStyle/>
+          <a:p>
+            <a:pPr indent="0" marL="0">
+              <a:buNone/>
+            </a:pPr>
+            <a:r>
+              <a:rPr lang="en-US" sz="2400" b="1" dirty="0">
+                <a:solidFill>
+                  <a:schemeClr val="accent1"/>
+                </a:solidFill>
+                <a:latin typeface="Cambria" pitchFamily="34" charset="0"/>
+                <a:ea typeface="Cambria" pitchFamily="34" charset="-122"/>
+                <a:cs typeface="Cambria" pitchFamily="34" charset="-120"/>
+              </a:rPr>
+              <a:t>0</a:t>
+            </a:r>
+            <a:endParaRPr lang="en-US" sz="2400" dirty="0"/>
+          </a:p>
+        </p:txBody>
+      </p:sp>
+      <p:sp>
+        <p:nvSpPr>
+          <p:cNvPr id="15" name="LLM card text 3"/>
+          <p:cNvSpPr txBox="1"/>
+          <p:nvPr/>
+        </p:nvSpPr>
+        <p:spPr>
+          <a:xfrm>
+            <a:off x="7406640" y="3639312"/>
+            <a:ext cx="1188720" cy="566928"/>
+          </a:xfrm>
+          <a:prstGeom prst="rect">
+            <a:avLst/>
+          </a:prstGeom>
+          <a:noFill/>
+          <a:ln/>
+        </p:spPr>
+        <p:txBody>
+          <a:bodyPr wrap="square" lIns="0" tIns="0" rIns="0" bIns="0" rtlCol="0" anchor="ctr"/>
+          <a:lstStyle/>
+          <a:p>
+            <a:pPr indent="0" marL="0">
+              <a:buNone/>
+            </a:pPr>
+            <a:r>
+              <a:rPr lang="en-US" sz="1100" dirty="0">
                 <a:solidFill>
                   <a:schemeClr val="tx1"/>
                 </a:solidFill>
               </a:rPr>
-              <a:t>Language-model extractor for real, messy documents</a:t>
-            </a:r>
-            <a:endParaRPr lang="en-US" sz="1400" dirty="0"/>
-          </a:p>
-          <a:p>
-            <a:pPr marL="342900" indent="-342900">
-              <a:spcAft>
-                <a:spcPts val="700"/>
-              </a:spcAft>
-              <a:buSzPct val="100000"/>
-              <a:buChar char="•"/>
-            </a:pPr>
-            <a:r>
-              <a:rPr lang="en-US" sz="1400" dirty="0">
-                <a:solidFill>
-                  <a:schemeClr val="tx1"/>
-                </a:solidFill>
-              </a:rPr>
-              <a:t>OCR for scanned bills and summaries</a:t>
-            </a:r>
-            <a:endParaRPr lang="en-US" sz="1400" dirty="0"/>
-          </a:p>
-          <a:p>
-            <a:pPr marL="342900" indent="-342900">
-              <a:spcAft>
-                <a:spcPts val="700"/>
-              </a:spcAft>
-              <a:buSzPct val="100000"/>
-              <a:buChar char="•"/>
-            </a:pPr>
-            <a:r>
-              <a:rPr lang="en-US" sz="1400" dirty="0">
-                <a:solidFill>
-                  <a:schemeClr val="tx1"/>
-                </a:solidFill>
-              </a:rPr>
-              <a:t>Strict mode: hold any claim whose history cannot be verified</a:t>
-            </a:r>
-            <a:endParaRPr lang="en-US" sz="1400" dirty="0"/>
-          </a:p>
-          <a:p>
-            <a:pPr marL="342900" indent="-342900">
-              <a:spcAft>
-                <a:spcPts val="700"/>
-              </a:spcAft>
-              <a:buSzPct val="100000"/>
-              <a:buChar char="•"/>
-            </a:pPr>
-            <a:r>
-              <a:rPr lang="en-US" sz="1400" dirty="0">
-                <a:solidFill>
-                  <a:schemeClr val="tx1"/>
-                </a:solidFill>
-              </a:rPr>
-              <a:t>Learn fraud weights from real outcomes, with human review feedback</a:t>
-            </a:r>
-            <a:endParaRPr lang="en-US" sz="1400" dirty="0"/>
+              <a:t>of 164 payable claims held by mistake</a:t>
+            </a:r>
+            <a:endParaRPr lang="en-US" sz="1100" dirty="0"/>
+          </a:p>
+        </p:txBody>
+      </p:sp>
+      <p:sp>
+        <p:nvSpPr>
+          <p:cNvPr id="16" name="LLM note"/>
+          <p:cNvSpPr txBox="1"/>
+          <p:nvPr/>
+        </p:nvSpPr>
+        <p:spPr>
+          <a:xfrm>
+            <a:off x="457200" y="4389120"/>
+            <a:ext cx="8138160" cy="320040"/>
+          </a:xfrm>
+          <a:prstGeom prst="rect">
+            <a:avLst/>
+          </a:prstGeom>
+          <a:noFill/>
+          <a:ln/>
+        </p:spPr>
+        <p:txBody>
+          <a:bodyPr wrap="square" lIns="0" tIns="0" rIns="0" bIns="0" rtlCol="0" anchor="t"/>
+          <a:lstStyle/>
+          <a:p>
+            <a:pPr indent="0" marL="0">
+              <a:buNone/>
+            </a:pPr>
+            <a:r>
+              <a:rPr lang="en-US" sz="1100" i="1" dirty="0">
+                <a:solidFill>
+                  <a:schemeClr val="tx2"/>
+                </a:solidFill>
+              </a:rPr>
+              <a:t>Same 89 claims for both columns. The model's prompt was tuned on other claims; telegraphic notes were written after tuning.</a:t>
+            </a:r>
+            <a:endParaRPr lang="en-US" sz="1100" dirty="0"/>
           </a:p>
         </p:txBody>
       </p:sp>
@@ -9009,8 +10008,8 @@
         </p:nvSpPr>
         <p:spPr>
           <a:xfrm>
-            <a:off x="548640" y="822960"/>
-            <a:ext cx="8046720" cy="822960"/>
+            <a:off x="457200" y="292608"/>
+            <a:ext cx="8229600" cy="777240"/>
           </a:xfrm>
           <a:prstGeom prst="rect">
             <a:avLst/>
@@ -9026,87 +10025,49 @@
               <a:buNone/>
             </a:pPr>
             <a:r>
-              <a:rPr lang="en-US" sz="4000" b="1" dirty="0">
-                <a:solidFill>
-                  <a:schemeClr val="bg1"/>
-                </a:solidFill>
-              </a:rPr>
-              <a:t>Thank you</a:t>
-            </a:r>
-            <a:endParaRPr lang="en-US" sz="4000" dirty="0"/>
-          </a:p>
-        </p:txBody>
-      </p:sp>
-      <p:sp>
-        <p:nvSpPr>
-          <p:cNvPr id="3" name="Text 0"/>
+              <a:rPr lang="en-US" sz="2800" b="1" dirty="0">
+                <a:solidFill>
+                  <a:schemeClr val="tx1"/>
+                </a:solidFill>
+              </a:rPr>
+              <a:t>Limitations and what comes next</a:t>
+            </a:r>
+            <a:endParaRPr lang="en-US" sz="2800" dirty="0"/>
+          </a:p>
+        </p:txBody>
+      </p:sp>
+      <p:sp>
+        <p:nvSpPr>
+          <p:cNvPr id="3" name="Limits card"/>
           <p:cNvSpPr/>
-          <p:nvPr>
-            <p:ph idx="101" type="body" hasCustomPrompt="1"/>
-          </p:nvPr>
-        </p:nvSpPr>
-        <p:spPr>
-          <a:xfrm>
-            <a:off x="548640" y="1691640"/>
-            <a:ext cx="7498080" cy="731520"/>
-          </a:xfrm>
-          <a:prstGeom prst="rect">
-            <a:avLst/>
-          </a:prstGeom>
-          <a:noFill/>
-          <a:ln/>
-        </p:spPr>
-        <p:txBody>
-          <a:bodyPr wrap="square" lIns="0" tIns="0" rIns="0" bIns="0" rtlCol="0" anchor="t"/>
-          <a:lstStyle/>
-          <a:p>
-            <a:pPr algn="l" indent="0" marL="0">
-              <a:buNone/>
-            </a:pPr>
-            <a:r>
-              <a:rPr lang="en-US" sz="1800" dirty="0">
-                <a:solidFill>
-                  <a:schemeClr val="bg2"/>
-                </a:solidFill>
-              </a:rPr>
-              <a:t>Questions welcome</a:t>
-            </a:r>
-            <a:endParaRPr lang="en-US" sz="1800" dirty="0"/>
-          </a:p>
-        </p:txBody>
-      </p:sp>
-      <p:sp>
-        <p:nvSpPr>
-          <p:cNvPr id="4" name="Closing members card"/>
-          <p:cNvSpPr/>
-          <p:nvPr/>
-        </p:nvSpPr>
-        <p:spPr>
-          <a:xfrm>
-            <a:off x="548640" y="2651760"/>
-            <a:ext cx="8046720" cy="1051560"/>
+          <p:nvPr/>
+        </p:nvSpPr>
+        <p:spPr>
+          <a:xfrm>
+            <a:off x="457200" y="1234440"/>
+            <a:ext cx="3977640" cy="3246120"/>
           </a:xfrm>
           <a:prstGeom prst="roundRect">
             <a:avLst>
-              <a:gd name="adj" fmla="val 6957"/>
+              <a:gd name="adj" fmla="val 2254"/>
             </a:avLst>
           </a:prstGeom>
           <a:solidFill>
-            <a:schemeClr val="tx2"/>
+            <a:schemeClr val="bg2"/>
           </a:solidFill>
           <a:ln/>
         </p:spPr>
       </p:sp>
       <p:sp>
         <p:nvSpPr>
-          <p:cNvPr id="5" name="Closing label"/>
-          <p:cNvSpPr txBox="1"/>
-          <p:nvPr/>
-        </p:nvSpPr>
-        <p:spPr>
-          <a:xfrm>
-            <a:off x="822960" y="2743200"/>
-            <a:ext cx="2743200" cy="228600"/>
+          <p:cNvPr id="4" name="Limits heading"/>
+          <p:cNvSpPr txBox="1"/>
+          <p:nvPr/>
+        </p:nvSpPr>
+        <p:spPr>
+          <a:xfrm>
+            <a:off x="685800" y="1371600"/>
+            <a:ext cx="3566160" cy="365760"/>
           </a:xfrm>
           <a:prstGeom prst="rect">
             <a:avLst/>
@@ -9122,51 +10083,15 @@
               <a:buNone/>
             </a:pPr>
             <a:r>
-              <a:rPr lang="en-US" sz="1100" b="1" spc="300" kern="0" dirty="0">
-                <a:solidFill>
-                  <a:schemeClr val="bg2"/>
-                </a:solidFill>
-              </a:rPr>
-              <a:t>GROUP MEMBERS</a:t>
-            </a:r>
-            <a:endParaRPr lang="en-US" sz="1100" dirty="0"/>
-          </a:p>
-        </p:txBody>
-      </p:sp>
-      <p:sp>
-        <p:nvSpPr>
-          <p:cNvPr id="6" name="Closing name 1"/>
-          <p:cNvSpPr txBox="1"/>
-          <p:nvPr/>
-        </p:nvSpPr>
-        <p:spPr>
-          <a:xfrm>
-            <a:off x="822960" y="3035808"/>
-            <a:ext cx="3017520" cy="365760"/>
-          </a:xfrm>
-          <a:prstGeom prst="rect">
-            <a:avLst/>
-          </a:prstGeom>
-          <a:noFill/>
-          <a:ln/>
-        </p:spPr>
-        <p:txBody>
-          <a:bodyPr wrap="square" lIns="0" tIns="0" rIns="0" bIns="0" rtlCol="0" anchor="t"/>
-          <a:lstStyle/>
-          <a:p>
-            <a:pPr indent="0" marL="0">
-              <a:buNone/>
-            </a:pPr>
-            <a:r>
               <a:rPr lang="en-US" sz="2000" b="1" dirty="0">
                 <a:solidFill>
-                  <a:schemeClr val="bg1"/>
+                  <a:schemeClr val="accent2"/>
                 </a:solidFill>
                 <a:latin typeface="Cambria" pitchFamily="34" charset="0"/>
                 <a:ea typeface="Cambria" pitchFamily="34" charset="-122"/>
                 <a:cs typeface="Cambria" pitchFamily="34" charset="-120"/>
               </a:rPr>
-              <a:t>Harsh Salunkhe</a:t>
+              <a:t>Limitations</a:t>
             </a:r>
             <a:endParaRPr lang="en-US" sz="2000" dirty="0"/>
           </a:p>
@@ -9174,14 +10099,14 @@
       </p:sp>
       <p:sp>
         <p:nvSpPr>
-          <p:cNvPr id="7" name="Closing roll 1"/>
-          <p:cNvSpPr txBox="1"/>
-          <p:nvPr/>
-        </p:nvSpPr>
-        <p:spPr>
-          <a:xfrm>
-            <a:off x="822960" y="3419856"/>
-            <a:ext cx="3017520" cy="274320"/>
+          <p:cNvPr id="5" name="Limits list"/>
+          <p:cNvSpPr txBox="1"/>
+          <p:nvPr/>
+        </p:nvSpPr>
+        <p:spPr>
+          <a:xfrm>
+            <a:off x="685800" y="1828800"/>
+            <a:ext cx="3566160" cy="2560320"/>
           </a:xfrm>
           <a:prstGeom prst="rect">
             <a:avLst/>
@@ -9193,55 +10118,135 @@
           <a:bodyPr wrap="square" lIns="0" tIns="0" rIns="0" bIns="0" rtlCol="0" anchor="t"/>
           <a:lstStyle/>
           <a:p>
+            <a:pPr marL="342900" indent="-342900">
+              <a:spcAft>
+                <a:spcPts val="700"/>
+              </a:spcAft>
+              <a:buSzPct val="100000"/>
+              <a:buChar char="•"/>
+            </a:pPr>
+            <a:r>
+              <a:rPr lang="en-US" sz="1400" dirty="0">
+                <a:solidFill>
+                  <a:schemeClr val="tx1"/>
+                </a:solidFill>
+              </a:rPr>
+              <a:t>All data is synthetic and the summaries are templated</a:t>
+            </a:r>
+            <a:endParaRPr lang="en-US" sz="1400" dirty="0"/>
+          </a:p>
+          <a:p>
+            <a:pPr marL="342900" indent="-342900">
+              <a:spcAft>
+                <a:spcPts val="700"/>
+              </a:spcAft>
+              <a:buSzPct val="100000"/>
+              <a:buChar char="•"/>
+            </a:pPr>
+            <a:r>
+              <a:rPr lang="en-US" sz="1400" dirty="0">
+                <a:solidFill>
+                  <a:schemeClr val="tx1"/>
+                </a:solidFill>
+              </a:rPr>
+              <a:t>Clinical abbreviations can hide a pre-existing condition</a:t>
+            </a:r>
+            <a:endParaRPr lang="en-US" sz="1400" dirty="0"/>
+          </a:p>
+          <a:p>
+            <a:pPr marL="342900" indent="-342900">
+              <a:spcAft>
+                <a:spcPts val="700"/>
+              </a:spcAft>
+              <a:buSzPct val="100000"/>
+              <a:buChar char="•"/>
+            </a:pPr>
+            <a:r>
+              <a:rPr lang="en-US" sz="1400" dirty="0">
+                <a:solidFill>
+                  <a:schemeClr val="tx1"/>
+                </a:solidFill>
+              </a:rPr>
+              <a:t>Fraud weights and tariffs are hand-set, not learned</a:t>
+            </a:r>
+            <a:endParaRPr lang="en-US" sz="1400" dirty="0"/>
+          </a:p>
+          <a:p>
+            <a:pPr marL="342900" indent="-342900">
+              <a:spcAft>
+                <a:spcPts val="700"/>
+              </a:spcAft>
+              <a:buSzPct val="100000"/>
+              <a:buChar char="•"/>
+            </a:pPr>
+            <a:r>
+              <a:rPr lang="en-US" sz="1400" dirty="0">
+                <a:solidFill>
+                  <a:schemeClr val="tx1"/>
+                </a:solidFill>
+              </a:rPr>
+              <a:t>The 25-minute manual baseline is an assumption</a:t>
+            </a:r>
+            <a:endParaRPr lang="en-US" sz="1400" dirty="0"/>
+          </a:p>
+        </p:txBody>
+      </p:sp>
+      <p:sp>
+        <p:nvSpPr>
+          <p:cNvPr id="6" name="Future card"/>
+          <p:cNvSpPr/>
+          <p:nvPr/>
+        </p:nvSpPr>
+        <p:spPr>
+          <a:xfrm>
+            <a:off x="4709160" y="1234440"/>
+            <a:ext cx="3977640" cy="3246120"/>
+          </a:xfrm>
+          <a:prstGeom prst="roundRect">
+            <a:avLst>
+              <a:gd name="adj" fmla="val 2254"/>
+            </a:avLst>
+          </a:prstGeom>
+          <a:solidFill>
+            <a:schemeClr val="bg2"/>
+          </a:solidFill>
+          <a:ln/>
+        </p:spPr>
+      </p:sp>
+      <p:sp>
+        <p:nvSpPr>
+          <p:cNvPr id="7" name="Future heading"/>
+          <p:cNvSpPr txBox="1"/>
+          <p:nvPr/>
+        </p:nvSpPr>
+        <p:spPr>
+          <a:xfrm>
+            <a:off x="4937760" y="1371600"/>
+            <a:ext cx="3566160" cy="365760"/>
+          </a:xfrm>
+          <a:prstGeom prst="rect">
+            <a:avLst/>
+          </a:prstGeom>
+          <a:noFill/>
+          <a:ln/>
+        </p:spPr>
+        <p:txBody>
+          <a:bodyPr wrap="square" lIns="0" tIns="0" rIns="0" bIns="0" rtlCol="0" anchor="t"/>
+          <a:lstStyle/>
+          <a:p>
             <a:pPr indent="0" marL="0">
               <a:buNone/>
             </a:pPr>
             <a:r>
-              <a:rPr lang="en-US" sz="1400" dirty="0">
-                <a:solidFill>
-                  <a:schemeClr val="bg2"/>
-                </a:solidFill>
-              </a:rPr>
-              <a:t>24070126066</a:t>
-            </a:r>
-            <a:endParaRPr lang="en-US" sz="1400" dirty="0"/>
-          </a:p>
-        </p:txBody>
-      </p:sp>
-      <p:sp>
-        <p:nvSpPr>
-          <p:cNvPr id="8" name="Closing name 2"/>
-          <p:cNvSpPr txBox="1"/>
-          <p:nvPr/>
-        </p:nvSpPr>
-        <p:spPr>
-          <a:xfrm>
-            <a:off x="4023360" y="3035808"/>
-            <a:ext cx="3017520" cy="365760"/>
-          </a:xfrm>
-          <a:prstGeom prst="rect">
-            <a:avLst/>
-          </a:prstGeom>
-          <a:noFill/>
-          <a:ln/>
-        </p:spPr>
-        <p:txBody>
-          <a:bodyPr wrap="square" lIns="0" tIns="0" rIns="0" bIns="0" rtlCol="0" anchor="t"/>
-          <a:lstStyle/>
-          <a:p>
-            <a:pPr indent="0" marL="0">
-              <a:buNone/>
-            </a:pPr>
-            <a:r>
               <a:rPr lang="en-US" sz="2000" b="1" dirty="0">
                 <a:solidFill>
-                  <a:schemeClr val="bg1"/>
+                  <a:schemeClr val="accent1"/>
                 </a:solidFill>
                 <a:latin typeface="Cambria" pitchFamily="34" charset="0"/>
                 <a:ea typeface="Cambria" pitchFamily="34" charset="-122"/>
                 <a:cs typeface="Cambria" pitchFamily="34" charset="-120"/>
               </a:rPr>
-              <a:t>Dharna Sharma</a:t>
+              <a:t>Future scope</a:t>
             </a:r>
             <a:endParaRPr lang="en-US" sz="2000" dirty="0"/>
           </a:p>
@@ -9249,14 +10254,14 @@
       </p:sp>
       <p:sp>
         <p:nvSpPr>
-          <p:cNvPr id="9" name="Closing roll 2"/>
-          <p:cNvSpPr txBox="1"/>
-          <p:nvPr/>
-        </p:nvSpPr>
-        <p:spPr>
-          <a:xfrm>
-            <a:off x="4023360" y="3419856"/>
-            <a:ext cx="3017520" cy="274320"/>
+          <p:cNvPr id="8" name="Future list"/>
+          <p:cNvSpPr txBox="1"/>
+          <p:nvPr/>
+        </p:nvSpPr>
+        <p:spPr>
+          <a:xfrm>
+            <a:off x="4937760" y="1828800"/>
+            <a:ext cx="3566160" cy="2560320"/>
           </a:xfrm>
           <a:prstGeom prst="rect">
             <a:avLst/>
@@ -9268,54 +10273,121 @@
           <a:bodyPr wrap="square" lIns="0" tIns="0" rIns="0" bIns="0" rtlCol="0" anchor="t"/>
           <a:lstStyle/>
           <a:p>
-            <a:pPr indent="0" marL="0">
-              <a:buNone/>
+            <a:pPr marL="342900" indent="-342900">
+              <a:spcAft>
+                <a:spcPts val="700"/>
+              </a:spcAft>
+              <a:buSzPct val="100000"/>
+              <a:buChar char="•"/>
             </a:pPr>
             <a:r>
               <a:rPr lang="en-US" sz="1400" dirty="0">
                 <a:solidFill>
-                  <a:schemeClr val="bg2"/>
-                </a:solidFill>
-              </a:rPr>
-              <a:t>24070126053</a:t>
+                  <a:schemeClr val="tx1"/>
+                </a:solidFill>
+              </a:rPr>
+              <a:t>Language-model extractor for real, messy documents</a:t>
             </a:r>
             <a:endParaRPr lang="en-US" sz="1400" dirty="0"/>
           </a:p>
-        </p:txBody>
-      </p:sp>
-      <p:sp>
-        <p:nvSpPr>
-          <p:cNvPr id="10" name="Live app"/>
-          <p:cNvSpPr txBox="1"/>
-          <p:nvPr/>
-        </p:nvSpPr>
-        <p:spPr>
-          <a:xfrm>
-            <a:off x="548640" y="4114800"/>
-            <a:ext cx="8046720" cy="274320"/>
-          </a:xfrm>
-          <a:prstGeom prst="rect">
-            <a:avLst/>
-          </a:prstGeom>
-          <a:noFill/>
-          <a:ln/>
-        </p:spPr>
-        <p:txBody>
-          <a:bodyPr wrap="square" lIns="0" tIns="0" rIns="0" bIns="0" rtlCol="0" anchor="t"/>
-          <a:lstStyle/>
-          <a:p>
-            <a:pPr indent="0" marL="0">
-              <a:buNone/>
+          <a:p>
+            <a:pPr marL="342900" indent="-342900">
+              <a:spcAft>
+                <a:spcPts val="700"/>
+              </a:spcAft>
+              <a:buSzPct val="100000"/>
+              <a:buChar char="•"/>
             </a:pPr>
             <a:r>
               <a:rPr lang="en-US" sz="1400" dirty="0">
                 <a:solidFill>
-                  <a:schemeClr val="bg2"/>
-                </a:solidFill>
-              </a:rPr>
-              <a:t>Live app: claims-adjudication-agent.onrender.com</a:t>
+                  <a:schemeClr val="tx1"/>
+                </a:solidFill>
+              </a:rPr>
+              <a:t>OCR for scanned bills and summaries</a:t>
             </a:r>
             <a:endParaRPr lang="en-US" sz="1400" dirty="0"/>
+          </a:p>
+          <a:p>
+            <a:pPr marL="342900" indent="-342900">
+              <a:spcAft>
+                <a:spcPts val="700"/>
+              </a:spcAft>
+              <a:buSzPct val="100000"/>
+              <a:buChar char="•"/>
+            </a:pPr>
+            <a:r>
+              <a:rPr lang="en-US" sz="1400" dirty="0">
+                <a:solidFill>
+                  <a:schemeClr val="tx1"/>
+                </a:solidFill>
+              </a:rPr>
+              <a:t>Strict mode: hold any claim whose history cannot be verified</a:t>
+            </a:r>
+            <a:endParaRPr lang="en-US" sz="1400" dirty="0"/>
+          </a:p>
+          <a:p>
+            <a:pPr marL="342900" indent="-342900">
+              <a:spcAft>
+                <a:spcPts val="700"/>
+              </a:spcAft>
+              <a:buSzPct val="100000"/>
+              <a:buChar char="•"/>
+            </a:pPr>
+            <a:r>
+              <a:rPr lang="en-US" sz="1400" dirty="0">
+                <a:solidFill>
+                  <a:schemeClr val="tx1"/>
+                </a:solidFill>
+              </a:rPr>
+              <a:t>Learn fraud weights from real outcomes, with human review feedback</a:t>
+            </a:r>
+            <a:endParaRPr lang="en-US" sz="1400" dirty="0"/>
+          </a:p>
+        </p:txBody>
+      </p:sp>
+      <p:sp>
+        <p:nvSpPr>
+          <p:cNvPr id="25" name="Slide Number Placeholder 0"/>
+          <p:cNvSpPr>
+            <a:spLocks noGrp="1"/>
+          </p:cNvSpPr>
+          <p:nvPr>
+            <p:ph type="sldNum" sz="quarter" idx="4294967295"/>
+          </p:nvPr>
+        </p:nvSpPr>
+        <p:spPr>
+          <a:xfrm>
+            <a:off x="8321040" y="4773168"/>
+            <a:ext cx="457200" cy="228600"/>
+          </a:xfrm>
+          <a:prstGeom prst="rect">
+            <a:avLst/>
+          </a:prstGeom>
+          <a:extLst>
+            <a:ext uri="{C572A759-6A51-4108-AA02-DFA0A04FC94B}">
+              <ma14:wrappingTextBoxFlag xmlns:ma14="http://schemas.microsoft.com/office/mac/drawingml/2011/main" val="0"/>
+            </a:ext>
+          </a:extLst>
+        </p:spPr>
+        <p:txBody>
+          <a:bodyPr/>
+          <a:lstStyle>
+            <a:lvl1pPr>
+              <a:defRPr sz="1000">
+                <a:solidFill>
+                  <a:schemeClr val="tx2"/>
+                </a:solidFill>
+              </a:defRPr>
+            </a:lvl1pPr>
+          </a:lstStyle>
+          <a:p>
+            <a:pPr algn="r"/>
+            <a:fld id="{F7021451-1387-4CA6-816F-3879F97B5CBC}" type="slidenum">
+              <a:rPr b="0" lang="en-US"/>
+              <a:t>9</a:t>
+            </a:fld>
+            <a:endParaRPr lang="en-US"/>
           </a:p>
         </p:txBody>
       </p:sp>

</xml_diff>